<commit_message>
Alinha os slides de Indicadores Socioeconômicos à página de conteúdos
Partes das unidades identificadas pelos tópicos do sumário, tabelas da
página nos slides (dado, indicador e índice; eficiência, eficácia e
efetividade; dimensões do diagnóstico), slide de resumo ao final de
cada unidade e falas do roteiro de gravação nas anotações.

Co-Authored-By: Claude Opus 5.5 <noreply@anthropic.com>
Claude-Session: https://claude.ai/code/session_01PyQDDPKwUxu1Vg7o8uyr7W
</commit_message>
<xml_diff>
--- a/disciplina-08-indicadores-socioeconomicos/materiais/01_Unidade_1_Indicadores_Sociais_Conceito_e_Medidas.pptx
+++ b/disciplina-08-indicadores-socioeconomicos/materiais/01_Unidade_1_Indicadores_Sociais_Conceito_e_Medidas.pptx
@@ -34,9 +34,10 @@
     <p:sldId id="282" r:id="rId28"/>
     <p:sldId id="283" r:id="rId29"/>
     <p:sldId id="284" r:id="rId30"/>
+    <p:sldId id="285" r:id="rId31"/>
   </p:sldIdLst>
   <p:notesMasterIdLst>
-    <p:notesMasterId r:id="rId31"/>
+    <p:notesMasterId r:id="rId32"/>
   </p:notesMasterIdLst>
   <p:sldSz cx="9144000" cy="5143500"/>
   <p:notesSz cx="5143500" cy="9144000"/>
@@ -1454,7 +1455,7 @@
           <a:p>
             <a:r>
               <a:rPr lang="en-US" dirty="0"/>
-              <a:t/>
+              <a:t>Olá, turma! Sejam bem-vindos e bem-vindas à Unidade 1 da disciplina Indicadores Socioeconômicos na Gestão Pública. Eu sou o Prof. Dr. Cleiton Franco. Nesta videoaula, vamos entender por que a gestão pública precisa de indicadores e como um conceito social, como pobreza ou desenvolvimento, se transforma em uma medida. Uma dica para toda a disciplina: escolha desde já um município, de preferência aquele em que você vive ou trabalha, e acompanhe os indicadores dele em todas as unidades.</a:t>
             </a:r>
             <a:endParaRPr lang="en-US" dirty="0"/>
           </a:p>
@@ -1542,7 +1543,7 @@
           <a:p>
             <a:r>
               <a:rPr lang="en-US" dirty="0"/>
-              <a:t/>
+              <a:t>A tabela mostra três níveis de informação, com números hipotéticos. O dado bruto, como 18 óbitos de menores de 1 ano, é uma contagem: não permite comparar municípios de tamanhos diferentes. O indicador, 15 óbitos por mil nascidos vivos, relaciona o dado a uma base comparável. E o índice sintético, como um IDHM de 0,72, combina vários indicadores em um só número. Do dado ao índice, ganhamos comparabilidade e síntese, mas perdemos detalhe; por isso é preciso olhar os três níveis.</a:t>
             </a:r>
             <a:endParaRPr lang="en-US" dirty="0"/>
           </a:p>
@@ -1630,7 +1631,7 @@
           <a:p>
             <a:r>
               <a:rPr lang="en-US" dirty="0"/>
-              <a:t/>
+              <a:t>O gráfico mostra por que as taxas importam. [Apontar para as colunas.] O município A tem 60 óbitos de bebês, o maior número, mas também é o maior, com 4 mil nascidos vivos: a taxa é 15 por mil. O município C tem só 12 óbitos, mas em apenas 500 nascidos vivos: a taxa é 24 por mil, a maior das três. Quem olhasse só as contagens escolheria o município errado para priorizar. Para comparar territórios, use taxas, não números absolutos.</a:t>
             </a:r>
             <a:endParaRPr lang="en-US" dirty="0"/>
           </a:p>
@@ -1718,7 +1719,7 @@
           <a:p>
             <a:r>
               <a:rPr lang="en-US" dirty="0"/>
-              <a:t/>
+              <a:t>Vamos aos cálculos, com dados hipotéticos. Taxa: a mortalidade infantil é o número de óbitos de menores de 1 ano dividido pelos nascidos vivos, vezes mil: 18 dividido por 1.200, vezes mil, dá 15 por mil nascidos vivos. Proporção: 900 analfabetos em 9 mil pessoas de 15 anos ou mais, vezes 100, dá 10%. Razão: 24 médicos para 12 mil habitantes, vezes mil, dá 2 médicos por mil habitantes. E o número-índice: o valor do ano dividido pelo valor do ano-base, vezes 100, com o ano-base igual a 100. Sempre verifique o numerador, o denominador e a unidade: por mil, por cem mil ou porcentagem.</a:t>
             </a:r>
             <a:endParaRPr lang="en-US" dirty="0"/>
           </a:p>
@@ -1806,7 +1807,7 @@
           <a:p>
             <a:r>
               <a:rPr lang="en-US" dirty="0"/>
-              <a:t/>
+              <a:t>Como saber se um indicador é bom? Jannuzzi aponta várias propriedades. Relevância: responde a uma questão importante da agenda pública. Validade: mede de fato o conceito que se pretende medir. Confiabilidade: usa dados de boa qualidade, coletados com método consistente. Sensibilidade: capta as mudanças, inclusive as produzidas pela política. Especificidade: reflete o fenômeno de interesse, e não outros. Desagregabilidade: pode ser calculado por bairro, sexo, idade, cor ou raça. Também importam a periodicidade, a comunicabilidade, a factibilidade, ou seja, o custo, e a historicidade, isto é, a existência de uma série no tempo.</a:t>
             </a:r>
             <a:endParaRPr lang="en-US" dirty="0"/>
           </a:p>
@@ -1894,7 +1895,7 @@
           <a:p>
             <a:r>
               <a:rPr lang="en-US" dirty="0"/>
-              <a:t/>
+              <a:t>Os indicadores podem ser classificados por quatro critérios. Pela natureza: objetivos, como a taxa de matrícula, ou subjetivos, como a satisfação com o posto de saúde. Pela complexidade: simples, como a taxa de analfabetismo, ou sintéticos, como o IDH e o IDEB. Pelo fluxo da política: insumo, processo, resultado e impacto. E pelo uso: descritivos, que retratam a realidade, ou normativos, que comparam com um padrão desejado. Veja o exemplo da saúde materno-infantil: médicos por mil habitantes é um insumo; consultas de pré-natal realizadas, um processo; gestantes com sete ou mais consultas, um resultado; e a queda da mortalidade infantil, o impacto.</a:t>
             </a:r>
             <a:endParaRPr lang="en-US" dirty="0"/>
           </a:p>
@@ -1982,7 +1983,7 @@
           <a:p>
             <a:r>
               <a:rPr lang="en-US" dirty="0"/>
-              <a:t/>
+              <a:t>O índice sintético mais conhecido é o IDH, que combina três dimensões: longevidade, medida pela esperança de vida ao nascer; educação, pela escolaridade da população adulta e pelo fluxo escolar dos jovens; e renda per capita. O resultado vai de 0 a 1. No Brasil, o IDHM é calculado para os municípios e divulgado no Atlas do Desenvolvimento Humano. A vantagem é resumir o desenvolvimento em um número e facilitar comparações. O limite é esconder desigualdades internas e entre as dimensões, além de depender de escolhas de componentes e pesos, como discutem Guimarães e Jannuzzi, em 2005.</a:t>
             </a:r>
             <a:endParaRPr lang="en-US" dirty="0"/>
           </a:p>
@@ -2070,7 +2071,7 @@
           <a:p>
             <a:r>
               <a:rPr lang="en-US" dirty="0"/>
-              <a:t/>
+              <a:t>Vejamos o IDHM do Brasil e de Mato Grosso. [Apontar para as colunas.] Em 1991, os dois estavam na faixa “muito baixo”, abaixo de 0,500: o Brasil com 0,493 e Mato Grosso com 0,449. Em 2010, os dois chegaram à faixa “alto”: 0,727 e 0,725. Mato Grosso começou abaixo da média nacional e praticamente a alcançou. Repare que o IDHM é calculado com dados do Censo, e por isso a série é de dez em dez anos.</a:t>
             </a:r>
             <a:endParaRPr lang="en-US" dirty="0"/>
           </a:p>
@@ -2158,7 +2159,7 @@
           <a:p>
             <a:r>
               <a:rPr lang="en-US" dirty="0"/>
-              <a:t/>
+              <a:t>Agora, o que o número único esconde. [Apontar para as barras de cada dimensão.] Em 2010, a longevidade é a dimensão mais alta, acima de 0,8, e a educação, a mais baixa, em torno de 0,64, tanto no Brasil quanto em Mato Grosso. O índice geral é uma média geométrica das três dimensões. A lição é: antes de concluir algo pelo índice sintético, olhe sempre os seus componentes.</a:t>
             </a:r>
             <a:endParaRPr lang="en-US" dirty="0"/>
           </a:p>
@@ -2246,7 +2247,7 @@
           <a:p>
             <a:r>
               <a:rPr lang="en-US" dirty="0"/>
-              <a:t/>
+              <a:t>Vamos às atividades da Unidade 1, com as datas no SIGAA. Nesta semana, assista à videoaula de apresentação e a esta videoaula, e leia Jannuzzi. No fórum de apresentação, conte qual município você vai acompanhar na disciplina. E no fórum temático 1, escolha um indicador desse município e analise duas propriedades dele. Todas as entregas vão até as 23h55. Na próxima unidade, vamos estudar os indicadores no ciclo das políticas públicas e o diagnóstico socioeconômico.</a:t>
             </a:r>
             <a:endParaRPr lang="en-US" dirty="0"/>
           </a:p>
@@ -2334,7 +2335,7 @@
           <a:p>
             <a:r>
               <a:rPr lang="en-US" dirty="0"/>
-              <a:t/>
+              <a:t>Para fechar, um quiz com cinco perguntas. Eu leio a pergunta, você pausa o vídeo, escolhe a sua resposta e confere a correção no slide seguinte. Vamos lá?</a:t>
             </a:r>
             <a:endParaRPr lang="en-US" dirty="0"/>
           </a:p>
@@ -2422,7 +2423,7 @@
           <a:p>
             <a:r>
               <a:rPr lang="en-US" dirty="0"/>
-              <a:t/>
+              <a:t>Um lembrete da organização. Esta é a primeira semana da disciplina; as datas estão no SIGAA. A leitura é o livro de Paulo Jannuzzi, Indicadores socioeconômicos na gestão pública, de 2014, e o texto de Jannuzzi de 2001, junto com os tópicos 1 e 2 do sumário da página de conteúdos. Nesta semana, você participa do fórum de apresentação e do fórum temático 1. A videoaula tem duas partes: a história dos indicadores e, depois, o caminho do conceito à medida.</a:t>
             </a:r>
             <a:endParaRPr lang="en-US" dirty="0"/>
           </a:p>
@@ -2510,7 +2511,7 @@
           <a:p>
             <a:r>
               <a:rPr lang="en-US" dirty="0"/>
-              <a:t/>
+              <a:t>Pergunta 1. O que o movimento dos indicadores sociais, nos anos 1960, criticava? Letra a: A existência dos censos. Letra b: Medir o bem-estar apenas pelo PIB. Letra c: O uso de taxas. Letra d: A criação do IBGE. Pause o vídeo e escolha a sua resposta.</a:t>
             </a:r>
             <a:endParaRPr lang="en-US" dirty="0"/>
           </a:p>
@@ -2598,7 +2599,7 @@
           <a:p>
             <a:r>
               <a:rPr lang="en-US" dirty="0"/>
-              <a:t/>
+              <a:t>A resposta correta é a letra b: Medir o bem-estar apenas pelo PIB. O crescimento do PIB não garantia melhores condições de vida; era preciso medir diretamente saúde, educação e moradia.</a:t>
             </a:r>
             <a:endParaRPr lang="en-US" dirty="0"/>
           </a:p>
@@ -2686,7 +2687,7 @@
           <a:p>
             <a:r>
               <a:rPr lang="en-US" dirty="0"/>
-              <a:t/>
+              <a:t>Pergunta 2. Com 18 óbitos de menores de 1 ano e 1.200 nascidos vivos, a taxa de mortalidade infantil é: Letra a: 1,5 por mil. Letra b: 18 por mil. Letra c: 15 por mil. Letra d: 150 por mil. Pause o vídeo e escolha a sua resposta.</a:t>
             </a:r>
             <a:endParaRPr lang="en-US" dirty="0"/>
           </a:p>
@@ -2774,7 +2775,7 @@
           <a:p>
             <a:r>
               <a:rPr lang="en-US" dirty="0"/>
-              <a:t/>
+              <a:t>A resposta correta é a letra c: 15 por mil. 18 ÷ 1.200 × 1.000 = 15 óbitos por mil nascidos vivos.</a:t>
             </a:r>
             <a:endParaRPr lang="en-US" dirty="0"/>
           </a:p>
@@ -2862,7 +2863,7 @@
           <a:p>
             <a:r>
               <a:rPr lang="en-US" dirty="0"/>
-              <a:t/>
+              <a:t>Pergunta 3. Um indicador que mede de fato o conceito que pretende medir tem: Letra a: Validade. Letra b: Periodicidade. Letra c: Comunicabilidade. Letra d: Historicidade. Pause o vídeo e escolha a sua resposta.</a:t>
             </a:r>
             <a:endParaRPr lang="en-US" dirty="0"/>
           </a:p>
@@ -2950,7 +2951,7 @@
           <a:p>
             <a:r>
               <a:rPr lang="en-US" dirty="0"/>
-              <a:t/>
+              <a:t>A resposta correta é a letra a: Validade. Validade é a correspondência entre a medida e o conceito.</a:t>
             </a:r>
             <a:endParaRPr lang="en-US" dirty="0"/>
           </a:p>
@@ -3038,7 +3039,7 @@
           <a:p>
             <a:r>
               <a:rPr lang="en-US" dirty="0"/>
-              <a:t/>
+              <a:t>Pergunta 4. O IDHM é um exemplo de indicador: Letra a: Subjetivo. Letra b: De insumo. Letra c: Simples. Letra d: Sintético (composto). Pause o vídeo e escolha a sua resposta.</a:t>
             </a:r>
             <a:endParaRPr lang="en-US" dirty="0"/>
           </a:p>
@@ -3126,7 +3127,7 @@
           <a:p>
             <a:r>
               <a:rPr lang="en-US" dirty="0"/>
-              <a:t/>
+              <a:t>A resposta correta é a letra d: Sintético (composto). Combina longevidade, educação e renda em um único índice.</a:t>
             </a:r>
             <a:endParaRPr lang="en-US" dirty="0"/>
           </a:p>
@@ -3214,7 +3215,7 @@
           <a:p>
             <a:r>
               <a:rPr lang="en-US" dirty="0"/>
-              <a:t/>
+              <a:t>Pergunta 5. O número de consultas de pré-natal realizadas é um indicador de: Letra a: Insumo. Letra b: Processo. Letra c: Impacto. Letra d: Contexto. Pause o vídeo e escolha a sua resposta.</a:t>
             </a:r>
             <a:endParaRPr lang="en-US" dirty="0"/>
           </a:p>
@@ -3302,7 +3303,7 @@
           <a:p>
             <a:r>
               <a:rPr lang="en-US" dirty="0"/>
-              <a:t/>
+              <a:t>A resposta correta é a letra b: Processo. Mede a execução das ações do programa (processo). O impacto seria a queda da mortalidade infantil.</a:t>
             </a:r>
             <a:endParaRPr lang="en-US" dirty="0"/>
           </a:p>
@@ -3390,7 +3391,7 @@
           <a:p>
             <a:r>
               <a:rPr lang="en-US" dirty="0"/>
-              <a:t/>
+              <a:t>Começamos pela Parte 1, que corresponde ao tópico 1 do sumário: uma breve caracterização histórica. Por que e como passamos a medir a realidade social?</a:t>
             </a:r>
             <a:endParaRPr lang="en-US" dirty="0"/>
           </a:p>
@@ -3414,6 +3415,94 @@
             <a:fld id="{F7021451-1387-4CA6-816F-3879F97B5CBC}" type="slidenum">
               <a:rPr lang="en-US"/>
               <a:t>3</a:t>
+            </a:fld>
+            <a:endParaRPr lang="en-US"/>
+          </a:p>
+        </p:txBody>
+      </p:sp>
+    </p:spTree>
+    <p:extLst>
+      <p:ext uri="{BB962C8B-B14F-4D97-AF65-F5344CB8AC3E}">
+        <p14:creationId xmlns:p14="http://schemas.microsoft.com/office/powerpoint/2010/main" val="1024086991"/>
+      </p:ext>
+    </p:extLst>
+  </p:cSld>
+  <p:clrMapOvr>
+    <a:masterClrMapping/>
+  </p:clrMapOvr>
+</p:notes>
+</file>
+
+<file path=ppt/notesSlides/notesSlide30.xml><?xml version="1.0" encoding="utf-8"?>
+<p:notes xmlns:a="http://schemas.openxmlformats.org/drawingml/2006/main" xmlns:r="http://schemas.openxmlformats.org/officeDocument/2006/relationships" xmlns:p="http://schemas.openxmlformats.org/presentationml/2006/main">
+  <p:cSld>
+    <p:spTree>
+      <p:nvGrpSpPr>
+        <p:cNvPr id="1" name=""/>
+        <p:cNvGrpSpPr/>
+        <p:nvPr/>
+      </p:nvGrpSpPr>
+      <p:grpSpPr>
+        <a:xfrm>
+          <a:off x="0" y="0"/>
+          <a:ext cx="0" cy="0"/>
+          <a:chOff x="0" y="0"/>
+          <a:chExt cx="0" cy="0"/>
+        </a:xfrm>
+      </p:grpSpPr>
+      <p:sp>
+        <p:nvSpPr>
+          <p:cNvPr id="2" name="Slide Image Placeholder 1"/>
+          <p:cNvSpPr>
+            <a:spLocks noGrp="1" noRot="1" noChangeAspect="1"/>
+          </p:cNvSpPr>
+          <p:nvPr>
+            <p:ph type="sldImg"/>
+          </p:nvPr>
+        </p:nvSpPr>
+        <p:spPr/>
+      </p:sp>
+      <p:sp>
+        <p:nvSpPr>
+          <p:cNvPr id="3" name="Notes Placeholder 2"/>
+          <p:cNvSpPr>
+            <a:spLocks noGrp="1"/>
+          </p:cNvSpPr>
+          <p:nvPr>
+            <p:ph type="body" idx="1"/>
+          </p:nvPr>
+        </p:nvSpPr>
+        <p:spPr/>
+        <p:txBody>
+          <a:bodyPr/>
+          <a:lstStyle/>
+          <a:p>
+            <a:r>
+              <a:rPr lang="en-US" dirty="0"/>
+              <a:t>Para fechar a Unidade 1, vamos recapitular. [Apontar para o quadro da esquerda.] No tópico 1, vimos que os indicadores servem para diagnosticar, planejar, monitorar, avaliar e para o controle social. Percorremos a história, dos censos e da criação do IBGE ao movimento dos indicadores sociais, ao IDH e aos ODS, e vimos que o PIB mede a produção, mas não mostra a distribuição da renda nem o acesso a serviços. [Apontar para o quadro da direita.] No tópico 2, definimos indicador social com Jannuzzi, vimos o caminho do conceito ao indicador, a diferença entre dado, indicador e índice, como calcular taxas, proporções, razões e números-índice, as propriedades de um bom indicador, as classificações e os índices sintéticos, com os seus limites. Na próxima unidade, indicadores no ciclo das políticas e o diagnóstico socioeconômico. Até lá!</a:t>
+            </a:r>
+            <a:endParaRPr lang="en-US" dirty="0"/>
+          </a:p>
+        </p:txBody>
+      </p:sp>
+      <p:sp>
+        <p:nvSpPr>
+          <p:cNvPr id="4" name="Slide Number Placeholder 3"/>
+          <p:cNvSpPr>
+            <a:spLocks noGrp="1"/>
+          </p:cNvSpPr>
+          <p:nvPr>
+            <p:ph type="sldNum" sz="quarter" idx="10"/>
+          </p:nvPr>
+        </p:nvSpPr>
+        <p:spPr/>
+        <p:txBody>
+          <a:bodyPr/>
+          <a:lstStyle/>
+          <a:p>
+            <a:fld id="{F7021451-1387-4CA6-816F-3879F97B5CBC}" type="slidenum">
+              <a:rPr lang="en-US"/>
+              <a:t>30</a:t>
             </a:fld>
             <a:endParaRPr lang="en-US"/>
           </a:p>
@@ -3478,7 +3567,7 @@
           <a:p>
             <a:r>
               <a:rPr lang="en-US" dirty="0"/>
-              <a:t/>
+              <a:t>Governar exige informação. Sem dados, o gestor decide às cegas: não sabe quem precisa de uma política, quanto precisa e se a ação funcionou. Os indicadores servem para quatro coisas: diagnosticar os problemas e quem é mais afetado; planejar, definindo prioridades, metas e recursos; monitorar a execução das ações; e avaliar resultados e impactos. E há um quinto uso, muito importante na democracia: o controle social. Com dados públicos, a população pode cobrar metas.</a:t>
             </a:r>
             <a:endParaRPr lang="en-US" dirty="0"/>
           </a:p>
@@ -3566,7 +3655,7 @@
           <a:p>
             <a:r>
               <a:rPr lang="en-US" dirty="0"/>
-              <a:t/>
+              <a:t>Vamos a uma breve história. No século XIX, consolidam-se as estatísticas oficiais e os censos; no Brasil, o primeiro recenseamento geral é de 1872, e o IBGE surge em 1936. Entre 1930 e 1950, com as contas nacionais, o PIB se torna a principal medida do desempenho das economias. Nos anos 1960, nos Estados Unidos, surge o movimento dos indicadores sociais: crescer não bastava, era preciso medir saúde, educação, moradia e condições de vida. Em 1990, o PNUD lança o IDH. Depois vêm os Objetivos do Milênio e a Agenda 2030, com 17 Objetivos de Desenvolvimento Sustentável. E hoje contamos com dados abertos, portais públicos e registros administrativos digitais.</a:t>
             </a:r>
             <a:endParaRPr lang="en-US" dirty="0"/>
           </a:p>
@@ -3654,7 +3743,7 @@
           <a:p>
             <a:r>
               <a:rPr lang="en-US" dirty="0"/>
-              <a:t/>
+              <a:t>Por que o PIB não basta? Ele mostra o valor da produção de bens e serviços finais, o ritmo de crescimento e a renda média por habitante. Mas esconde como a renda se distribui, o acesso a saúde, educação e saneamento, e os custos ambientais e o trabalho não pago. Um exemplo bem próximo de nós: um município pode ter PIB per capita elevado, graças ao agronegócio, e ainda assim muitas famílias em situação de pobreza. Por isso precisamos de indicadores sociais.</a:t>
             </a:r>
             <a:endParaRPr lang="en-US" dirty="0"/>
           </a:p>
@@ -3742,7 +3831,7 @@
           <a:p>
             <a:r>
               <a:rPr lang="en-US" dirty="0"/>
-              <a:t/>
+              <a:t>Agora, a Parte 2, que corresponde ao tópico 2 do sumário: indicadores sociais, do conceito às medidas. Vamos ver o conceito, o cálculo, as propriedades, as classificações e os índices sintéticos.</a:t>
             </a:r>
             <a:endParaRPr lang="en-US" dirty="0"/>
           </a:p>
@@ -3830,7 +3919,7 @@
           <a:p>
             <a:r>
               <a:rPr lang="en-US" dirty="0"/>
-              <a:t/>
+              <a:t>Segundo Paulo Jannuzzi, indicador social é uma medida, em geral quantitativa, dotada de significado social, usada para substituir, quantificar ou operacionalizar um conceito social abstrato, de interesse teórico ou programático. Em outras palavras: pobreza, desenvolvimento e qualidade da educação são ideias que não se observam diretamente. Renda per capita, taxa de analfabetismo e IDEB são números que representam esses conceitos.</a:t>
             </a:r>
             <a:endParaRPr lang="en-US" dirty="0"/>
           </a:p>
@@ -3918,7 +4007,7 @@
           <a:p>
             <a:r>
               <a:rPr lang="en-US" dirty="0"/>
-              <a:t/>
+              <a:t>Como se chega do conceito ao indicador? Vamos pelo exemplo da pobreza, em quatro passos. Primeiro, o conceito: pobreza como privação de condições básicas de vida. Segundo, as dimensões: renda, moradia, acesso a água e esgoto, educação. Terceiro, os dados: o Censo, a PNAD Contínua ou o CadÚnico. Quarto, o indicador: por exemplo, a proporção de pessoas com renda per capita abaixo de uma linha de pobreza. Atenção: a escolha das dimensões e da linha de corte muda o resultado. Todo indicador envolve decisões metodológicas.</a:t>
             </a:r>
             <a:endParaRPr lang="en-US" dirty="0"/>
           </a:p>
@@ -4623,303 +4712,870 @@
           </a:p>
         </p:txBody>
       </p:sp>
-      <p:sp>
-        <p:nvSpPr>
-          <p:cNvPr id="3" name="Text 1"/>
+      <p:graphicFrame>
+        <p:nvGraphicFramePr>
+          <p:cNvPr id="11" name="Table 0"/>
+          <p:cNvGraphicFramePr>
+            <a:graphicFrameLocks noGrp="1"/>
+          </p:cNvGraphicFramePr>
+          <p:nvPr>
+            <p:extLst>
+              <p:ext uri="{D42A27DB-BD31-4B8C-83A1-F6EECF244321}">
+                <p14:modId xmlns:p14="http://schemas.microsoft.com/office/powerpoint/2010/main" val="1579011935"/>
+              </p:ext>
+            </p:extLst>
+          </p:nvPr>
+        </p:nvGraphicFramePr>
+        <p:xfrm>
+          <a:off x="685800" y="1234440"/>
+          <a:ext cx="7772400" cy="914400"/>
+        </p:xfrm>
+        <a:graphic>
+          <a:graphicData uri="http://schemas.openxmlformats.org/drawingml/2006/table">
+            <a:tbl>
+              <a:tblPr/>
+              <a:tblGrid>
+                <a:gridCol w="1920240"/>
+                <a:gridCol w="2743200"/>
+                <a:gridCol w="3108960"/>
+              </a:tblGrid>
+              <a:tr h="0">
+                <a:tc>
+                  <a:txBody>
+                    <a:bodyPr/>
+                    <a:lstStyle/>
+                    <a:p>
+                      <a:pPr indent="0" marL="0">
+                        <a:buNone/>
+                      </a:pPr>
+                      <a:r>
+                        <a:rPr lang="en-US" sz="1400" b="1" dirty="0">
+                          <a:solidFill>
+                            <a:srgbClr val="FFFFFF"/>
+                          </a:solidFill>
+                          <a:latin typeface="Calibri" pitchFamily="34" charset="0"/>
+                          <a:ea typeface="Calibri" pitchFamily="34" charset="-122"/>
+                          <a:cs typeface="Calibri" pitchFamily="34" charset="-120"/>
+                        </a:rPr>
+                        <a:t>Nível</a:t>
+                      </a:r>
+                      <a:endParaRPr lang="en-US" sz="1400" dirty="0">
+                        <a:latin typeface="Calibri" charset="0"/>
+                        <a:ea typeface="Calibri" charset="0"/>
+                        <a:cs typeface="Calibri" charset="0"/>
+                      </a:endParaRPr>
+                    </a:p>
+                  </a:txBody>
+                  <a:tcPr marL="50800" marR="50800" marT="50800" marB="50800" anchor="ctr">
+                    <a:lnL w="9525" cap="flat" cmpd="sng" algn="ctr">
+                      <a:solidFill>
+                        <a:srgbClr val="DCD5C1"/>
+                      </a:solidFill>
+                      <a:prstDash val="solid"/>
+                      <a:round/>
+                      <a:headEnd type="none" w="med" len="med"/>
+                      <a:tailEnd type="none" w="med" len="med"/>
+                    </a:lnL>
+                    <a:lnR w="9525" cap="flat" cmpd="sng" algn="ctr">
+                      <a:solidFill>
+                        <a:srgbClr val="DCD5C1"/>
+                      </a:solidFill>
+                      <a:prstDash val="solid"/>
+                      <a:round/>
+                      <a:headEnd type="none" w="med" len="med"/>
+                      <a:tailEnd type="none" w="med" len="med"/>
+                    </a:lnR>
+                    <a:lnT w="9525" cap="flat" cmpd="sng" algn="ctr">
+                      <a:solidFill>
+                        <a:srgbClr val="DCD5C1"/>
+                      </a:solidFill>
+                      <a:prstDash val="solid"/>
+                      <a:round/>
+                      <a:headEnd type="none" w="med" len="med"/>
+                      <a:tailEnd type="none" w="med" len="med"/>
+                    </a:lnT>
+                    <a:lnB w="9525" cap="flat" cmpd="sng" algn="ctr">
+                      <a:solidFill>
+                        <a:srgbClr val="DCD5C1"/>
+                      </a:solidFill>
+                      <a:prstDash val="solid"/>
+                      <a:round/>
+                      <a:headEnd type="none" w="med" len="med"/>
+                      <a:tailEnd type="none" w="med" len="med"/>
+                    </a:lnB>
+                    <a:solidFill>
+                      <a:srgbClr val="13294B"/>
+                    </a:solidFill>
+                  </a:tcPr>
+                </a:tc>
+                <a:tc>
+                  <a:txBody>
+                    <a:bodyPr/>
+                    <a:lstStyle/>
+                    <a:p>
+                      <a:pPr indent="0" marL="0">
+                        <a:buNone/>
+                      </a:pPr>
+                      <a:r>
+                        <a:rPr lang="en-US" sz="1400" b="1" dirty="0">
+                          <a:solidFill>
+                            <a:srgbClr val="FFFFFF"/>
+                          </a:solidFill>
+                          <a:latin typeface="Calibri" pitchFamily="34" charset="0"/>
+                          <a:ea typeface="Calibri" pitchFamily="34" charset="-122"/>
+                          <a:cs typeface="Calibri" pitchFamily="34" charset="-120"/>
+                        </a:rPr>
+                        <a:t>Exemplo (hipotético)</a:t>
+                      </a:r>
+                      <a:endParaRPr lang="en-US" sz="1400" dirty="0">
+                        <a:latin typeface="Calibri" charset="0"/>
+                        <a:ea typeface="Calibri" charset="0"/>
+                        <a:cs typeface="Calibri" charset="0"/>
+                      </a:endParaRPr>
+                    </a:p>
+                  </a:txBody>
+                  <a:tcPr marL="50800" marR="50800" marT="50800" marB="50800" anchor="ctr">
+                    <a:lnL w="9525" cap="flat" cmpd="sng" algn="ctr">
+                      <a:solidFill>
+                        <a:srgbClr val="DCD5C1"/>
+                      </a:solidFill>
+                      <a:prstDash val="solid"/>
+                      <a:round/>
+                      <a:headEnd type="none" w="med" len="med"/>
+                      <a:tailEnd type="none" w="med" len="med"/>
+                    </a:lnL>
+                    <a:lnR w="9525" cap="flat" cmpd="sng" algn="ctr">
+                      <a:solidFill>
+                        <a:srgbClr val="DCD5C1"/>
+                      </a:solidFill>
+                      <a:prstDash val="solid"/>
+                      <a:round/>
+                      <a:headEnd type="none" w="med" len="med"/>
+                      <a:tailEnd type="none" w="med" len="med"/>
+                    </a:lnR>
+                    <a:lnT w="9525" cap="flat" cmpd="sng" algn="ctr">
+                      <a:solidFill>
+                        <a:srgbClr val="DCD5C1"/>
+                      </a:solidFill>
+                      <a:prstDash val="solid"/>
+                      <a:round/>
+                      <a:headEnd type="none" w="med" len="med"/>
+                      <a:tailEnd type="none" w="med" len="med"/>
+                    </a:lnT>
+                    <a:lnB w="9525" cap="flat" cmpd="sng" algn="ctr">
+                      <a:solidFill>
+                        <a:srgbClr val="DCD5C1"/>
+                      </a:solidFill>
+                      <a:prstDash val="solid"/>
+                      <a:round/>
+                      <a:headEnd type="none" w="med" len="med"/>
+                      <a:tailEnd type="none" w="med" len="med"/>
+                    </a:lnB>
+                    <a:solidFill>
+                      <a:srgbClr val="13294B"/>
+                    </a:solidFill>
+                  </a:tcPr>
+                </a:tc>
+                <a:tc>
+                  <a:txBody>
+                    <a:bodyPr/>
+                    <a:lstStyle/>
+                    <a:p>
+                      <a:pPr indent="0" marL="0">
+                        <a:buNone/>
+                      </a:pPr>
+                      <a:r>
+                        <a:rPr lang="en-US" sz="1400" b="1" dirty="0">
+                          <a:solidFill>
+                            <a:srgbClr val="FFFFFF"/>
+                          </a:solidFill>
+                          <a:latin typeface="Calibri" pitchFamily="34" charset="0"/>
+                          <a:ea typeface="Calibri" pitchFamily="34" charset="-122"/>
+                          <a:cs typeface="Calibri" pitchFamily="34" charset="-120"/>
+                        </a:rPr>
+                        <a:t>Para que serve</a:t>
+                      </a:r>
+                      <a:endParaRPr lang="en-US" sz="1400" dirty="0">
+                        <a:latin typeface="Calibri" charset="0"/>
+                        <a:ea typeface="Calibri" charset="0"/>
+                        <a:cs typeface="Calibri" charset="0"/>
+                      </a:endParaRPr>
+                    </a:p>
+                  </a:txBody>
+                  <a:tcPr marL="50800" marR="50800" marT="50800" marB="50800" anchor="ctr">
+                    <a:lnL w="9525" cap="flat" cmpd="sng" algn="ctr">
+                      <a:solidFill>
+                        <a:srgbClr val="DCD5C1"/>
+                      </a:solidFill>
+                      <a:prstDash val="solid"/>
+                      <a:round/>
+                      <a:headEnd type="none" w="med" len="med"/>
+                      <a:tailEnd type="none" w="med" len="med"/>
+                    </a:lnL>
+                    <a:lnR w="9525" cap="flat" cmpd="sng" algn="ctr">
+                      <a:solidFill>
+                        <a:srgbClr val="DCD5C1"/>
+                      </a:solidFill>
+                      <a:prstDash val="solid"/>
+                      <a:round/>
+                      <a:headEnd type="none" w="med" len="med"/>
+                      <a:tailEnd type="none" w="med" len="med"/>
+                    </a:lnR>
+                    <a:lnT w="9525" cap="flat" cmpd="sng" algn="ctr">
+                      <a:solidFill>
+                        <a:srgbClr val="DCD5C1"/>
+                      </a:solidFill>
+                      <a:prstDash val="solid"/>
+                      <a:round/>
+                      <a:headEnd type="none" w="med" len="med"/>
+                      <a:tailEnd type="none" w="med" len="med"/>
+                    </a:lnT>
+                    <a:lnB w="9525" cap="flat" cmpd="sng" algn="ctr">
+                      <a:solidFill>
+                        <a:srgbClr val="DCD5C1"/>
+                      </a:solidFill>
+                      <a:prstDash val="solid"/>
+                      <a:round/>
+                      <a:headEnd type="none" w="med" len="med"/>
+                      <a:tailEnd type="none" w="med" len="med"/>
+                    </a:lnB>
+                    <a:solidFill>
+                      <a:srgbClr val="13294B"/>
+                    </a:solidFill>
+                  </a:tcPr>
+                </a:tc>
+              </a:tr>
+              <a:tr h="0">
+                <a:tc>
+                  <a:txBody>
+                    <a:bodyPr/>
+                    <a:lstStyle/>
+                    <a:p>
+                      <a:pPr indent="0" marL="0">
+                        <a:buNone/>
+                      </a:pPr>
+                      <a:r>
+                        <a:rPr lang="en-US" sz="1400" b="1" dirty="0">
+                          <a:solidFill>
+                            <a:srgbClr val="1F2A37"/>
+                          </a:solidFill>
+                          <a:latin typeface="Calibri" pitchFamily="34" charset="0"/>
+                          <a:ea typeface="Calibri" pitchFamily="34" charset="-122"/>
+                          <a:cs typeface="Calibri" pitchFamily="34" charset="-120"/>
+                        </a:rPr>
+                        <a:t>Dado bruto</a:t>
+                      </a:r>
+                      <a:endParaRPr lang="en-US" sz="1400" dirty="0">
+                        <a:latin typeface="Calibri" charset="0"/>
+                        <a:ea typeface="Calibri" charset="0"/>
+                        <a:cs typeface="Calibri" charset="0"/>
+                      </a:endParaRPr>
+                    </a:p>
+                  </a:txBody>
+                  <a:tcPr marL="50800" marR="50800" marT="50800" marB="50800" anchor="ctr">
+                    <a:lnL w="9525" cap="flat" cmpd="sng" algn="ctr">
+                      <a:solidFill>
+                        <a:srgbClr val="DCD5C1"/>
+                      </a:solidFill>
+                      <a:prstDash val="solid"/>
+                      <a:round/>
+                      <a:headEnd type="none" w="med" len="med"/>
+                      <a:tailEnd type="none" w="med" len="med"/>
+                    </a:lnL>
+                    <a:lnR w="9525" cap="flat" cmpd="sng" algn="ctr">
+                      <a:solidFill>
+                        <a:srgbClr val="DCD5C1"/>
+                      </a:solidFill>
+                      <a:prstDash val="solid"/>
+                      <a:round/>
+                      <a:headEnd type="none" w="med" len="med"/>
+                      <a:tailEnd type="none" w="med" len="med"/>
+                    </a:lnR>
+                    <a:lnT w="9525" cap="flat" cmpd="sng" algn="ctr">
+                      <a:solidFill>
+                        <a:srgbClr val="DCD5C1"/>
+                      </a:solidFill>
+                      <a:prstDash val="solid"/>
+                      <a:round/>
+                      <a:headEnd type="none" w="med" len="med"/>
+                      <a:tailEnd type="none" w="med" len="med"/>
+                    </a:lnT>
+                    <a:lnB w="9525" cap="flat" cmpd="sng" algn="ctr">
+                      <a:solidFill>
+                        <a:srgbClr val="DCD5C1"/>
+                      </a:solidFill>
+                      <a:prstDash val="solid"/>
+                      <a:round/>
+                      <a:headEnd type="none" w="med" len="med"/>
+                      <a:tailEnd type="none" w="med" len="med"/>
+                    </a:lnB>
+                    <a:solidFill>
+                      <a:srgbClr val="FFFFFF"/>
+                    </a:solidFill>
+                  </a:tcPr>
+                </a:tc>
+                <a:tc>
+                  <a:txBody>
+                    <a:bodyPr/>
+                    <a:lstStyle/>
+                    <a:p>
+                      <a:pPr indent="0" marL="0">
+                        <a:buNone/>
+                      </a:pPr>
+                      <a:r>
+                        <a:rPr lang="en-US" sz="1400" dirty="0">
+                          <a:solidFill>
+                            <a:srgbClr val="1F2A37"/>
+                          </a:solidFill>
+                          <a:latin typeface="Calibri" pitchFamily="34" charset="0"/>
+                          <a:ea typeface="Calibri" pitchFamily="34" charset="-122"/>
+                          <a:cs typeface="Calibri" pitchFamily="34" charset="-120"/>
+                        </a:rPr>
+                        <a:t>18 óbitos de menores de 1 ano</a:t>
+                      </a:r>
+                      <a:endParaRPr lang="en-US" sz="1400" dirty="0">
+                        <a:latin typeface="Calibri" charset="0"/>
+                        <a:ea typeface="Calibri" charset="0"/>
+                        <a:cs typeface="Calibri" charset="0"/>
+                      </a:endParaRPr>
+                    </a:p>
+                  </a:txBody>
+                  <a:tcPr marL="50800" marR="50800" marT="50800" marB="50800" anchor="ctr">
+                    <a:lnL w="9525" cap="flat" cmpd="sng" algn="ctr">
+                      <a:solidFill>
+                        <a:srgbClr val="DCD5C1"/>
+                      </a:solidFill>
+                      <a:prstDash val="solid"/>
+                      <a:round/>
+                      <a:headEnd type="none" w="med" len="med"/>
+                      <a:tailEnd type="none" w="med" len="med"/>
+                    </a:lnL>
+                    <a:lnR w="9525" cap="flat" cmpd="sng" algn="ctr">
+                      <a:solidFill>
+                        <a:srgbClr val="DCD5C1"/>
+                      </a:solidFill>
+                      <a:prstDash val="solid"/>
+                      <a:round/>
+                      <a:headEnd type="none" w="med" len="med"/>
+                      <a:tailEnd type="none" w="med" len="med"/>
+                    </a:lnR>
+                    <a:lnT w="9525" cap="flat" cmpd="sng" algn="ctr">
+                      <a:solidFill>
+                        <a:srgbClr val="DCD5C1"/>
+                      </a:solidFill>
+                      <a:prstDash val="solid"/>
+                      <a:round/>
+                      <a:headEnd type="none" w="med" len="med"/>
+                      <a:tailEnd type="none" w="med" len="med"/>
+                    </a:lnT>
+                    <a:lnB w="9525" cap="flat" cmpd="sng" algn="ctr">
+                      <a:solidFill>
+                        <a:srgbClr val="DCD5C1"/>
+                      </a:solidFill>
+                      <a:prstDash val="solid"/>
+                      <a:round/>
+                      <a:headEnd type="none" w="med" len="med"/>
+                      <a:tailEnd type="none" w="med" len="med"/>
+                    </a:lnB>
+                    <a:solidFill>
+                      <a:srgbClr val="FFFFFF"/>
+                    </a:solidFill>
+                  </a:tcPr>
+                </a:tc>
+                <a:tc>
+                  <a:txBody>
+                    <a:bodyPr/>
+                    <a:lstStyle/>
+                    <a:p>
+                      <a:pPr indent="0" marL="0">
+                        <a:buNone/>
+                      </a:pPr>
+                      <a:r>
+                        <a:rPr lang="en-US" sz="1400" dirty="0">
+                          <a:solidFill>
+                            <a:srgbClr val="1F2A37"/>
+                          </a:solidFill>
+                          <a:latin typeface="Calibri" pitchFamily="34" charset="0"/>
+                          <a:ea typeface="Calibri" pitchFamily="34" charset="-122"/>
+                          <a:cs typeface="Calibri" pitchFamily="34" charset="-120"/>
+                        </a:rPr>
+                        <a:t>Contagem; não permite comparar municípios de tamanhos diferentes</a:t>
+                      </a:r>
+                      <a:endParaRPr lang="en-US" sz="1400" dirty="0">
+                        <a:latin typeface="Calibri" charset="0"/>
+                        <a:ea typeface="Calibri" charset="0"/>
+                        <a:cs typeface="Calibri" charset="0"/>
+                      </a:endParaRPr>
+                    </a:p>
+                  </a:txBody>
+                  <a:tcPr marL="50800" marR="50800" marT="50800" marB="50800" anchor="ctr">
+                    <a:lnL w="9525" cap="flat" cmpd="sng" algn="ctr">
+                      <a:solidFill>
+                        <a:srgbClr val="DCD5C1"/>
+                      </a:solidFill>
+                      <a:prstDash val="solid"/>
+                      <a:round/>
+                      <a:headEnd type="none" w="med" len="med"/>
+                      <a:tailEnd type="none" w="med" len="med"/>
+                    </a:lnL>
+                    <a:lnR w="9525" cap="flat" cmpd="sng" algn="ctr">
+                      <a:solidFill>
+                        <a:srgbClr val="DCD5C1"/>
+                      </a:solidFill>
+                      <a:prstDash val="solid"/>
+                      <a:round/>
+                      <a:headEnd type="none" w="med" len="med"/>
+                      <a:tailEnd type="none" w="med" len="med"/>
+                    </a:lnR>
+                    <a:lnT w="9525" cap="flat" cmpd="sng" algn="ctr">
+                      <a:solidFill>
+                        <a:srgbClr val="DCD5C1"/>
+                      </a:solidFill>
+                      <a:prstDash val="solid"/>
+                      <a:round/>
+                      <a:headEnd type="none" w="med" len="med"/>
+                      <a:tailEnd type="none" w="med" len="med"/>
+                    </a:lnT>
+                    <a:lnB w="9525" cap="flat" cmpd="sng" algn="ctr">
+                      <a:solidFill>
+                        <a:srgbClr val="DCD5C1"/>
+                      </a:solidFill>
+                      <a:prstDash val="solid"/>
+                      <a:round/>
+                      <a:headEnd type="none" w="med" len="med"/>
+                      <a:tailEnd type="none" w="med" len="med"/>
+                    </a:lnB>
+                    <a:solidFill>
+                      <a:srgbClr val="FFFFFF"/>
+                    </a:solidFill>
+                  </a:tcPr>
+                </a:tc>
+              </a:tr>
+              <a:tr h="0">
+                <a:tc>
+                  <a:txBody>
+                    <a:bodyPr/>
+                    <a:lstStyle/>
+                    <a:p>
+                      <a:pPr indent="0" marL="0">
+                        <a:buNone/>
+                      </a:pPr>
+                      <a:r>
+                        <a:rPr lang="en-US" sz="1400" b="1" dirty="0">
+                          <a:solidFill>
+                            <a:srgbClr val="1F2A37"/>
+                          </a:solidFill>
+                          <a:latin typeface="Calibri" pitchFamily="34" charset="0"/>
+                          <a:ea typeface="Calibri" pitchFamily="34" charset="-122"/>
+                          <a:cs typeface="Calibri" pitchFamily="34" charset="-120"/>
+                        </a:rPr>
+                        <a:t>Indicador</a:t>
+                      </a:r>
+                      <a:endParaRPr lang="en-US" sz="1400" dirty="0">
+                        <a:latin typeface="Calibri" charset="0"/>
+                        <a:ea typeface="Calibri" charset="0"/>
+                        <a:cs typeface="Calibri" charset="0"/>
+                      </a:endParaRPr>
+                    </a:p>
+                  </a:txBody>
+                  <a:tcPr marL="50800" marR="50800" marT="50800" marB="50800" anchor="ctr">
+                    <a:lnL w="9525" cap="flat" cmpd="sng" algn="ctr">
+                      <a:solidFill>
+                        <a:srgbClr val="DCD5C1"/>
+                      </a:solidFill>
+                      <a:prstDash val="solid"/>
+                      <a:round/>
+                      <a:headEnd type="none" w="med" len="med"/>
+                      <a:tailEnd type="none" w="med" len="med"/>
+                    </a:lnL>
+                    <a:lnR w="9525" cap="flat" cmpd="sng" algn="ctr">
+                      <a:solidFill>
+                        <a:srgbClr val="DCD5C1"/>
+                      </a:solidFill>
+                      <a:prstDash val="solid"/>
+                      <a:round/>
+                      <a:headEnd type="none" w="med" len="med"/>
+                      <a:tailEnd type="none" w="med" len="med"/>
+                    </a:lnR>
+                    <a:lnT w="9525" cap="flat" cmpd="sng" algn="ctr">
+                      <a:solidFill>
+                        <a:srgbClr val="DCD5C1"/>
+                      </a:solidFill>
+                      <a:prstDash val="solid"/>
+                      <a:round/>
+                      <a:headEnd type="none" w="med" len="med"/>
+                      <a:tailEnd type="none" w="med" len="med"/>
+                    </a:lnT>
+                    <a:lnB w="9525" cap="flat" cmpd="sng" algn="ctr">
+                      <a:solidFill>
+                        <a:srgbClr val="DCD5C1"/>
+                      </a:solidFill>
+                      <a:prstDash val="solid"/>
+                      <a:round/>
+                      <a:headEnd type="none" w="med" len="med"/>
+                      <a:tailEnd type="none" w="med" len="med"/>
+                    </a:lnB>
+                    <a:solidFill>
+                      <a:srgbClr val="F4F7F8"/>
+                    </a:solidFill>
+                  </a:tcPr>
+                </a:tc>
+                <a:tc>
+                  <a:txBody>
+                    <a:bodyPr/>
+                    <a:lstStyle/>
+                    <a:p>
+                      <a:pPr indent="0" marL="0">
+                        <a:buNone/>
+                      </a:pPr>
+                      <a:r>
+                        <a:rPr lang="en-US" sz="1400" dirty="0">
+                          <a:solidFill>
+                            <a:srgbClr val="1F2A37"/>
+                          </a:solidFill>
+                          <a:latin typeface="Calibri" pitchFamily="34" charset="0"/>
+                          <a:ea typeface="Calibri" pitchFamily="34" charset="-122"/>
+                          <a:cs typeface="Calibri" pitchFamily="34" charset="-120"/>
+                        </a:rPr>
+                        <a:t>15 óbitos por mil nascidos vivos</a:t>
+                      </a:r>
+                      <a:endParaRPr lang="en-US" sz="1400" dirty="0">
+                        <a:latin typeface="Calibri" charset="0"/>
+                        <a:ea typeface="Calibri" charset="0"/>
+                        <a:cs typeface="Calibri" charset="0"/>
+                      </a:endParaRPr>
+                    </a:p>
+                  </a:txBody>
+                  <a:tcPr marL="50800" marR="50800" marT="50800" marB="50800" anchor="ctr">
+                    <a:lnL w="9525" cap="flat" cmpd="sng" algn="ctr">
+                      <a:solidFill>
+                        <a:srgbClr val="DCD5C1"/>
+                      </a:solidFill>
+                      <a:prstDash val="solid"/>
+                      <a:round/>
+                      <a:headEnd type="none" w="med" len="med"/>
+                      <a:tailEnd type="none" w="med" len="med"/>
+                    </a:lnL>
+                    <a:lnR w="9525" cap="flat" cmpd="sng" algn="ctr">
+                      <a:solidFill>
+                        <a:srgbClr val="DCD5C1"/>
+                      </a:solidFill>
+                      <a:prstDash val="solid"/>
+                      <a:round/>
+                      <a:headEnd type="none" w="med" len="med"/>
+                      <a:tailEnd type="none" w="med" len="med"/>
+                    </a:lnR>
+                    <a:lnT w="9525" cap="flat" cmpd="sng" algn="ctr">
+                      <a:solidFill>
+                        <a:srgbClr val="DCD5C1"/>
+                      </a:solidFill>
+                      <a:prstDash val="solid"/>
+                      <a:round/>
+                      <a:headEnd type="none" w="med" len="med"/>
+                      <a:tailEnd type="none" w="med" len="med"/>
+                    </a:lnT>
+                    <a:lnB w="9525" cap="flat" cmpd="sng" algn="ctr">
+                      <a:solidFill>
+                        <a:srgbClr val="DCD5C1"/>
+                      </a:solidFill>
+                      <a:prstDash val="solid"/>
+                      <a:round/>
+                      <a:headEnd type="none" w="med" len="med"/>
+                      <a:tailEnd type="none" w="med" len="med"/>
+                    </a:lnB>
+                    <a:solidFill>
+                      <a:srgbClr val="F4F7F8"/>
+                    </a:solidFill>
+                  </a:tcPr>
+                </a:tc>
+                <a:tc>
+                  <a:txBody>
+                    <a:bodyPr/>
+                    <a:lstStyle/>
+                    <a:p>
+                      <a:pPr indent="0" marL="0">
+                        <a:buNone/>
+                      </a:pPr>
+                      <a:r>
+                        <a:rPr lang="en-US" sz="1400" dirty="0">
+                          <a:solidFill>
+                            <a:srgbClr val="1F2A37"/>
+                          </a:solidFill>
+                          <a:latin typeface="Calibri" pitchFamily="34" charset="0"/>
+                          <a:ea typeface="Calibri" pitchFamily="34" charset="-122"/>
+                          <a:cs typeface="Calibri" pitchFamily="34" charset="-120"/>
+                        </a:rPr>
+                        <a:t>Relaciona o dado a uma base comparável</a:t>
+                      </a:r>
+                      <a:endParaRPr lang="en-US" sz="1400" dirty="0">
+                        <a:latin typeface="Calibri" charset="0"/>
+                        <a:ea typeface="Calibri" charset="0"/>
+                        <a:cs typeface="Calibri" charset="0"/>
+                      </a:endParaRPr>
+                    </a:p>
+                  </a:txBody>
+                  <a:tcPr marL="50800" marR="50800" marT="50800" marB="50800" anchor="ctr">
+                    <a:lnL w="9525" cap="flat" cmpd="sng" algn="ctr">
+                      <a:solidFill>
+                        <a:srgbClr val="DCD5C1"/>
+                      </a:solidFill>
+                      <a:prstDash val="solid"/>
+                      <a:round/>
+                      <a:headEnd type="none" w="med" len="med"/>
+                      <a:tailEnd type="none" w="med" len="med"/>
+                    </a:lnL>
+                    <a:lnR w="9525" cap="flat" cmpd="sng" algn="ctr">
+                      <a:solidFill>
+                        <a:srgbClr val="DCD5C1"/>
+                      </a:solidFill>
+                      <a:prstDash val="solid"/>
+                      <a:round/>
+                      <a:headEnd type="none" w="med" len="med"/>
+                      <a:tailEnd type="none" w="med" len="med"/>
+                    </a:lnR>
+                    <a:lnT w="9525" cap="flat" cmpd="sng" algn="ctr">
+                      <a:solidFill>
+                        <a:srgbClr val="DCD5C1"/>
+                      </a:solidFill>
+                      <a:prstDash val="solid"/>
+                      <a:round/>
+                      <a:headEnd type="none" w="med" len="med"/>
+                      <a:tailEnd type="none" w="med" len="med"/>
+                    </a:lnT>
+                    <a:lnB w="9525" cap="flat" cmpd="sng" algn="ctr">
+                      <a:solidFill>
+                        <a:srgbClr val="DCD5C1"/>
+                      </a:solidFill>
+                      <a:prstDash val="solid"/>
+                      <a:round/>
+                      <a:headEnd type="none" w="med" len="med"/>
+                      <a:tailEnd type="none" w="med" len="med"/>
+                    </a:lnB>
+                    <a:solidFill>
+                      <a:srgbClr val="F4F7F8"/>
+                    </a:solidFill>
+                  </a:tcPr>
+                </a:tc>
+              </a:tr>
+              <a:tr h="0">
+                <a:tc>
+                  <a:txBody>
+                    <a:bodyPr/>
+                    <a:lstStyle/>
+                    <a:p>
+                      <a:pPr indent="0" marL="0">
+                        <a:buNone/>
+                      </a:pPr>
+                      <a:r>
+                        <a:rPr lang="en-US" sz="1400" b="1" dirty="0">
+                          <a:solidFill>
+                            <a:srgbClr val="1F2A37"/>
+                          </a:solidFill>
+                          <a:latin typeface="Calibri" pitchFamily="34" charset="0"/>
+                          <a:ea typeface="Calibri" pitchFamily="34" charset="-122"/>
+                          <a:cs typeface="Calibri" pitchFamily="34" charset="-120"/>
+                        </a:rPr>
+                        <a:t>Índice sintético</a:t>
+                      </a:r>
+                      <a:endParaRPr lang="en-US" sz="1400" dirty="0">
+                        <a:latin typeface="Calibri" charset="0"/>
+                        <a:ea typeface="Calibri" charset="0"/>
+                        <a:cs typeface="Calibri" charset="0"/>
+                      </a:endParaRPr>
+                    </a:p>
+                  </a:txBody>
+                  <a:tcPr marL="50800" marR="50800" marT="50800" marB="50800" anchor="ctr">
+                    <a:lnL w="9525" cap="flat" cmpd="sng" algn="ctr">
+                      <a:solidFill>
+                        <a:srgbClr val="DCD5C1"/>
+                      </a:solidFill>
+                      <a:prstDash val="solid"/>
+                      <a:round/>
+                      <a:headEnd type="none" w="med" len="med"/>
+                      <a:tailEnd type="none" w="med" len="med"/>
+                    </a:lnL>
+                    <a:lnR w="9525" cap="flat" cmpd="sng" algn="ctr">
+                      <a:solidFill>
+                        <a:srgbClr val="DCD5C1"/>
+                      </a:solidFill>
+                      <a:prstDash val="solid"/>
+                      <a:round/>
+                      <a:headEnd type="none" w="med" len="med"/>
+                      <a:tailEnd type="none" w="med" len="med"/>
+                    </a:lnR>
+                    <a:lnT w="9525" cap="flat" cmpd="sng" algn="ctr">
+                      <a:solidFill>
+                        <a:srgbClr val="DCD5C1"/>
+                      </a:solidFill>
+                      <a:prstDash val="solid"/>
+                      <a:round/>
+                      <a:headEnd type="none" w="med" len="med"/>
+                      <a:tailEnd type="none" w="med" len="med"/>
+                    </a:lnT>
+                    <a:lnB w="9525" cap="flat" cmpd="sng" algn="ctr">
+                      <a:solidFill>
+                        <a:srgbClr val="DCD5C1"/>
+                      </a:solidFill>
+                      <a:prstDash val="solid"/>
+                      <a:round/>
+                      <a:headEnd type="none" w="med" len="med"/>
+                      <a:tailEnd type="none" w="med" len="med"/>
+                    </a:lnB>
+                    <a:solidFill>
+                      <a:srgbClr val="FFFFFF"/>
+                    </a:solidFill>
+                  </a:tcPr>
+                </a:tc>
+                <a:tc>
+                  <a:txBody>
+                    <a:bodyPr/>
+                    <a:lstStyle/>
+                    <a:p>
+                      <a:pPr indent="0" marL="0">
+                        <a:buNone/>
+                      </a:pPr>
+                      <a:r>
+                        <a:rPr lang="en-US" sz="1400" dirty="0">
+                          <a:solidFill>
+                            <a:srgbClr val="1F2A37"/>
+                          </a:solidFill>
+                          <a:latin typeface="Calibri" pitchFamily="34" charset="0"/>
+                          <a:ea typeface="Calibri" pitchFamily="34" charset="-122"/>
+                          <a:cs typeface="Calibri" pitchFamily="34" charset="-120"/>
+                        </a:rPr>
+                        <a:t>IDHM = 0,72</a:t>
+                      </a:r>
+                      <a:endParaRPr lang="en-US" sz="1400" dirty="0">
+                        <a:latin typeface="Calibri" charset="0"/>
+                        <a:ea typeface="Calibri" charset="0"/>
+                        <a:cs typeface="Calibri" charset="0"/>
+                      </a:endParaRPr>
+                    </a:p>
+                  </a:txBody>
+                  <a:tcPr marL="50800" marR="50800" marT="50800" marB="50800" anchor="ctr">
+                    <a:lnL w="9525" cap="flat" cmpd="sng" algn="ctr">
+                      <a:solidFill>
+                        <a:srgbClr val="DCD5C1"/>
+                      </a:solidFill>
+                      <a:prstDash val="solid"/>
+                      <a:round/>
+                      <a:headEnd type="none" w="med" len="med"/>
+                      <a:tailEnd type="none" w="med" len="med"/>
+                    </a:lnL>
+                    <a:lnR w="9525" cap="flat" cmpd="sng" algn="ctr">
+                      <a:solidFill>
+                        <a:srgbClr val="DCD5C1"/>
+                      </a:solidFill>
+                      <a:prstDash val="solid"/>
+                      <a:round/>
+                      <a:headEnd type="none" w="med" len="med"/>
+                      <a:tailEnd type="none" w="med" len="med"/>
+                    </a:lnR>
+                    <a:lnT w="9525" cap="flat" cmpd="sng" algn="ctr">
+                      <a:solidFill>
+                        <a:srgbClr val="DCD5C1"/>
+                      </a:solidFill>
+                      <a:prstDash val="solid"/>
+                      <a:round/>
+                      <a:headEnd type="none" w="med" len="med"/>
+                      <a:tailEnd type="none" w="med" len="med"/>
+                    </a:lnT>
+                    <a:lnB w="9525" cap="flat" cmpd="sng" algn="ctr">
+                      <a:solidFill>
+                        <a:srgbClr val="DCD5C1"/>
+                      </a:solidFill>
+                      <a:prstDash val="solid"/>
+                      <a:round/>
+                      <a:headEnd type="none" w="med" len="med"/>
+                      <a:tailEnd type="none" w="med" len="med"/>
+                    </a:lnB>
+                    <a:solidFill>
+                      <a:srgbClr val="FFFFFF"/>
+                    </a:solidFill>
+                  </a:tcPr>
+                </a:tc>
+                <a:tc>
+                  <a:txBody>
+                    <a:bodyPr/>
+                    <a:lstStyle/>
+                    <a:p>
+                      <a:pPr indent="0" marL="0">
+                        <a:buNone/>
+                      </a:pPr>
+                      <a:r>
+                        <a:rPr lang="en-US" sz="1400" dirty="0">
+                          <a:solidFill>
+                            <a:srgbClr val="1F2A37"/>
+                          </a:solidFill>
+                          <a:latin typeface="Calibri" pitchFamily="34" charset="0"/>
+                          <a:ea typeface="Calibri" pitchFamily="34" charset="-122"/>
+                          <a:cs typeface="Calibri" pitchFamily="34" charset="-120"/>
+                        </a:rPr>
+                        <a:t>Combina vários indicadores em um número</a:t>
+                      </a:r>
+                      <a:endParaRPr lang="en-US" sz="1400" dirty="0">
+                        <a:latin typeface="Calibri" charset="0"/>
+                        <a:ea typeface="Calibri" charset="0"/>
+                        <a:cs typeface="Calibri" charset="0"/>
+                      </a:endParaRPr>
+                    </a:p>
+                  </a:txBody>
+                  <a:tcPr marL="50800" marR="50800" marT="50800" marB="50800" anchor="ctr">
+                    <a:lnL w="9525" cap="flat" cmpd="sng" algn="ctr">
+                      <a:solidFill>
+                        <a:srgbClr val="DCD5C1"/>
+                      </a:solidFill>
+                      <a:prstDash val="solid"/>
+                      <a:round/>
+                      <a:headEnd type="none" w="med" len="med"/>
+                      <a:tailEnd type="none" w="med" len="med"/>
+                    </a:lnL>
+                    <a:lnR w="9525" cap="flat" cmpd="sng" algn="ctr">
+                      <a:solidFill>
+                        <a:srgbClr val="DCD5C1"/>
+                      </a:solidFill>
+                      <a:prstDash val="solid"/>
+                      <a:round/>
+                      <a:headEnd type="none" w="med" len="med"/>
+                      <a:tailEnd type="none" w="med" len="med"/>
+                    </a:lnR>
+                    <a:lnT w="9525" cap="flat" cmpd="sng" algn="ctr">
+                      <a:solidFill>
+                        <a:srgbClr val="DCD5C1"/>
+                      </a:solidFill>
+                      <a:prstDash val="solid"/>
+                      <a:round/>
+                      <a:headEnd type="none" w="med" len="med"/>
+                      <a:tailEnd type="none" w="med" len="med"/>
+                    </a:lnT>
+                    <a:lnB w="9525" cap="flat" cmpd="sng" algn="ctr">
+                      <a:solidFill>
+                        <a:srgbClr val="DCD5C1"/>
+                      </a:solidFill>
+                      <a:prstDash val="solid"/>
+                      <a:round/>
+                      <a:headEnd type="none" w="med" len="med"/>
+                      <a:tailEnd type="none" w="med" len="med"/>
+                    </a:lnB>
+                    <a:solidFill>
+                      <a:srgbClr val="FFFFFF"/>
+                    </a:solidFill>
+                  </a:tcPr>
+                </a:tc>
+              </a:tr>
+            </a:tbl>
+          </a:graphicData>
+        </a:graphic>
+      </p:graphicFrame>
+      <p:sp>
+        <p:nvSpPr>
+          <p:cNvPr id="4" name="Text 1"/>
           <p:cNvSpPr txBox="1"/>
           <p:nvPr/>
         </p:nvSpPr>
         <p:spPr>
           <a:xfrm>
-            <a:off x="685800" y="1280160"/>
-            <a:ext cx="2456688" cy="1920240"/>
-          </a:xfrm>
-          <a:prstGeom prst="roundRect">
-            <a:avLst>
-              <a:gd name="adj" fmla="val 2857"/>
-            </a:avLst>
-          </a:prstGeom>
-          <a:solidFill>
-            <a:srgbClr val="FFFFFF"/>
-          </a:solidFill>
-          <a:ln w="12700">
-            <a:solidFill>
-              <a:srgbClr val="DCD5C1"/>
-            </a:solidFill>
-          </a:ln>
-        </p:spPr>
-        <p:txBody>
-          <a:bodyPr wrap="square" lIns="101600" tIns="101600" rIns="101600" bIns="101600" rtlCol="0" anchor="t"/>
-          <a:lstStyle/>
-          <a:p>
-            <a:pPr algn="l" indent="0" marL="0">
-              <a:lnSpc>
-                <a:spcPct val="100000"/>
-              </a:lnSpc>
-              <a:spcAft>
-                <a:spcPts val="200"/>
-              </a:spcAft>
-              <a:buNone/>
-            </a:pPr>
-            <a:r>
-              <a:rPr lang="en-US" sz="1100" b="1" dirty="0">
-                <a:solidFill>
-                  <a:srgbClr val="2A8C85"/>
-                </a:solidFill>
-                <a:latin typeface="Calibri" pitchFamily="34" charset="0"/>
-                <a:ea typeface="Calibri" pitchFamily="34" charset="-122"/>
-                <a:cs typeface="Calibri" pitchFamily="34" charset="-120"/>
-              </a:rPr>
-              <a:t>DADO BRUTO</a:t>
-            </a:r>
-            <a:endParaRPr lang="en-US" sz="1100" dirty="0"/>
-          </a:p>
-          <a:p>
-            <a:pPr algn="l" indent="0" marL="0">
-              <a:lnSpc>
-                <a:spcPct val="100000"/>
-              </a:lnSpc>
-              <a:spcAft>
-                <a:spcPts val="300"/>
-              </a:spcAft>
-              <a:buNone/>
-            </a:pPr>
-            <a:r>
-              <a:rPr lang="en-US" sz="1600" b="1" dirty="0">
-                <a:solidFill>
-                  <a:srgbClr val="13294B"/>
-                </a:solidFill>
-                <a:latin typeface="Calibri" pitchFamily="34" charset="0"/>
-                <a:ea typeface="Calibri" pitchFamily="34" charset="-122"/>
-                <a:cs typeface="Calibri" pitchFamily="34" charset="-120"/>
-              </a:rPr>
-              <a:t>18 óbitos de bebês</a:t>
-            </a:r>
-            <a:endParaRPr lang="en-US" sz="1100" dirty="0"/>
-          </a:p>
-          <a:p>
-            <a:pPr algn="l" indent="0" marL="0">
-              <a:lnSpc>
-                <a:spcPct val="100000"/>
-              </a:lnSpc>
-              <a:buNone/>
-            </a:pPr>
-            <a:r>
-              <a:rPr lang="en-US" sz="1350" dirty="0">
-                <a:solidFill>
-                  <a:srgbClr val="1F2A37"/>
-                </a:solidFill>
-                <a:latin typeface="Calibri" pitchFamily="34" charset="0"/>
-                <a:ea typeface="Calibri" pitchFamily="34" charset="-122"/>
-                <a:cs typeface="Calibri" pitchFamily="34" charset="-120"/>
-              </a:rPr>
-              <a:t>Contagem simples. Não permite comparar municípios de tamanhos diferentes.</a:t>
-            </a:r>
-            <a:endParaRPr lang="en-US" sz="1100" dirty="0"/>
-          </a:p>
-        </p:txBody>
-      </p:sp>
-      <p:sp>
-        <p:nvSpPr>
-          <p:cNvPr id="4" name="Text 2"/>
-          <p:cNvSpPr txBox="1"/>
-          <p:nvPr/>
-        </p:nvSpPr>
-        <p:spPr>
-          <a:xfrm>
-            <a:off x="3343656" y="1280160"/>
-            <a:ext cx="2456688" cy="1920240"/>
-          </a:xfrm>
-          <a:prstGeom prst="roundRect">
-            <a:avLst>
-              <a:gd name="adj" fmla="val 2857"/>
-            </a:avLst>
-          </a:prstGeom>
-          <a:solidFill>
-            <a:srgbClr val="FFFFFF"/>
-          </a:solidFill>
-          <a:ln w="12700">
-            <a:solidFill>
-              <a:srgbClr val="DCD5C1"/>
-            </a:solidFill>
-          </a:ln>
-        </p:spPr>
-        <p:txBody>
-          <a:bodyPr wrap="square" lIns="101600" tIns="101600" rIns="101600" bIns="101600" rtlCol="0" anchor="t"/>
-          <a:lstStyle/>
-          <a:p>
-            <a:pPr algn="l" indent="0" marL="0">
-              <a:lnSpc>
-                <a:spcPct val="100000"/>
-              </a:lnSpc>
-              <a:spcAft>
-                <a:spcPts val="200"/>
-              </a:spcAft>
-              <a:buNone/>
-            </a:pPr>
-            <a:r>
-              <a:rPr lang="en-US" sz="1100" b="1" dirty="0">
-                <a:solidFill>
-                  <a:srgbClr val="2A8C85"/>
-                </a:solidFill>
-                <a:latin typeface="Calibri" pitchFamily="34" charset="0"/>
-                <a:ea typeface="Calibri" pitchFamily="34" charset="-122"/>
-                <a:cs typeface="Calibri" pitchFamily="34" charset="-120"/>
-              </a:rPr>
-              <a:t>INDICADOR</a:t>
-            </a:r>
-            <a:endParaRPr lang="en-US" sz="1100" dirty="0"/>
-          </a:p>
-          <a:p>
-            <a:pPr algn="l" indent="0" marL="0">
-              <a:lnSpc>
-                <a:spcPct val="100000"/>
-              </a:lnSpc>
-              <a:spcAft>
-                <a:spcPts val="300"/>
-              </a:spcAft>
-              <a:buNone/>
-            </a:pPr>
-            <a:r>
-              <a:rPr lang="en-US" sz="1600" b="1" dirty="0">
-                <a:solidFill>
-                  <a:srgbClr val="13294B"/>
-                </a:solidFill>
-                <a:latin typeface="Calibri" pitchFamily="34" charset="0"/>
-                <a:ea typeface="Calibri" pitchFamily="34" charset="-122"/>
-                <a:cs typeface="Calibri" pitchFamily="34" charset="-120"/>
-              </a:rPr>
-              <a:t>15 por mil nascidos vivos</a:t>
-            </a:r>
-            <a:endParaRPr lang="en-US" sz="1100" dirty="0"/>
-          </a:p>
-          <a:p>
-            <a:pPr algn="l" indent="0" marL="0">
-              <a:lnSpc>
-                <a:spcPct val="100000"/>
-              </a:lnSpc>
-              <a:buNone/>
-            </a:pPr>
-            <a:r>
-              <a:rPr lang="en-US" sz="1350" dirty="0">
-                <a:solidFill>
-                  <a:srgbClr val="1F2A37"/>
-                </a:solidFill>
-                <a:latin typeface="Calibri" pitchFamily="34" charset="0"/>
-                <a:ea typeface="Calibri" pitchFamily="34" charset="-122"/>
-                <a:cs typeface="Calibri" pitchFamily="34" charset="-120"/>
-              </a:rPr>
-              <a:t>Taxa de mortalidade infantil: relaciona o dado a uma base comparável.</a:t>
-            </a:r>
-            <a:endParaRPr lang="en-US" sz="1100" dirty="0"/>
-          </a:p>
-        </p:txBody>
-      </p:sp>
-      <p:sp>
-        <p:nvSpPr>
-          <p:cNvPr id="5" name="Text 3"/>
-          <p:cNvSpPr txBox="1"/>
-          <p:nvPr/>
-        </p:nvSpPr>
-        <p:spPr>
-          <a:xfrm>
-            <a:off x="6001512" y="1280160"/>
-            <a:ext cx="2456688" cy="1920240"/>
-          </a:xfrm>
-          <a:prstGeom prst="roundRect">
-            <a:avLst>
-              <a:gd name="adj" fmla="val 2857"/>
-            </a:avLst>
-          </a:prstGeom>
-          <a:solidFill>
-            <a:srgbClr val="FFFFFF"/>
-          </a:solidFill>
-          <a:ln w="12700">
-            <a:solidFill>
-              <a:srgbClr val="DCD5C1"/>
-            </a:solidFill>
-          </a:ln>
-        </p:spPr>
-        <p:txBody>
-          <a:bodyPr wrap="square" lIns="101600" tIns="101600" rIns="101600" bIns="101600" rtlCol="0" anchor="t"/>
-          <a:lstStyle/>
-          <a:p>
-            <a:pPr algn="l" indent="0" marL="0">
-              <a:lnSpc>
-                <a:spcPct val="100000"/>
-              </a:lnSpc>
-              <a:spcAft>
-                <a:spcPts val="200"/>
-              </a:spcAft>
-              <a:buNone/>
-            </a:pPr>
-            <a:r>
-              <a:rPr lang="en-US" sz="1100" b="1" dirty="0">
-                <a:solidFill>
-                  <a:srgbClr val="2A8C85"/>
-                </a:solidFill>
-                <a:latin typeface="Calibri" pitchFamily="34" charset="0"/>
-                <a:ea typeface="Calibri" pitchFamily="34" charset="-122"/>
-                <a:cs typeface="Calibri" pitchFamily="34" charset="-120"/>
-              </a:rPr>
-              <a:t>ÍNDICE SINTÉTICO</a:t>
-            </a:r>
-            <a:endParaRPr lang="en-US" sz="1100" dirty="0"/>
-          </a:p>
-          <a:p>
-            <a:pPr algn="l" indent="0" marL="0">
-              <a:lnSpc>
-                <a:spcPct val="100000"/>
-              </a:lnSpc>
-              <a:spcAft>
-                <a:spcPts val="300"/>
-              </a:spcAft>
-              <a:buNone/>
-            </a:pPr>
-            <a:r>
-              <a:rPr lang="en-US" sz="1600" b="1" dirty="0">
-                <a:solidFill>
-                  <a:srgbClr val="13294B"/>
-                </a:solidFill>
-                <a:latin typeface="Calibri" pitchFamily="34" charset="0"/>
-                <a:ea typeface="Calibri" pitchFamily="34" charset="-122"/>
-                <a:cs typeface="Calibri" pitchFamily="34" charset="-120"/>
-              </a:rPr>
-              <a:t>IDHM 0,72</a:t>
-            </a:r>
-            <a:endParaRPr lang="en-US" sz="1100" dirty="0"/>
-          </a:p>
-          <a:p>
-            <a:pPr algn="l" indent="0" marL="0">
-              <a:lnSpc>
-                <a:spcPct val="100000"/>
-              </a:lnSpc>
-              <a:buNone/>
-            </a:pPr>
-            <a:r>
-              <a:rPr lang="en-US" sz="1350" dirty="0">
-                <a:solidFill>
-                  <a:srgbClr val="1F2A37"/>
-                </a:solidFill>
-                <a:latin typeface="Calibri" pitchFamily="34" charset="0"/>
-                <a:ea typeface="Calibri" pitchFamily="34" charset="-122"/>
-                <a:cs typeface="Calibri" pitchFamily="34" charset="-120"/>
-              </a:rPr>
-              <a:t>Combina vários indicadores (saúde, educação e renda) em um único número.</a:t>
-            </a:r>
-            <a:endParaRPr lang="en-US" sz="1100" dirty="0"/>
-          </a:p>
-        </p:txBody>
-      </p:sp>
-      <p:sp>
-        <p:nvSpPr>
-          <p:cNvPr id="6" name="Text 4"/>
-          <p:cNvSpPr txBox="1"/>
-          <p:nvPr/>
-        </p:nvSpPr>
-        <p:spPr>
-          <a:xfrm>
-            <a:off x="685800" y="3429000"/>
+            <a:off x="685800" y="3383280"/>
             <a:ext cx="7772400" cy="731520"/>
           </a:xfrm>
           <a:prstGeom prst="roundRect">
@@ -4943,7 +5599,7 @@
               <a:buNone/>
             </a:pPr>
             <a:r>
-              <a:rPr lang="en-US" sz="1300" dirty="0">
+              <a:rPr lang="en-US" sz="1400" dirty="0">
                 <a:solidFill>
                   <a:srgbClr val="13294B"/>
                 </a:solidFill>
@@ -4951,15 +5607,15 @@
                 <a:ea typeface="Calibri" pitchFamily="34" charset="-122"/>
                 <a:cs typeface="Calibri" pitchFamily="34" charset="-120"/>
               </a:rPr>
-              <a:t>Números hipotéticos, para ilustração.</a:t>
-            </a:r>
-            <a:endParaRPr lang="en-US" sz="1300" dirty="0"/>
-          </a:p>
-        </p:txBody>
-      </p:sp>
-      <p:sp>
-        <p:nvSpPr>
-          <p:cNvPr id="7" name="Text 5"/>
+              <a:t>Do dado ao índice, ganha-se comparabilidade e síntese, mas perde-se detalhe: por isso é preciso olhar os três níveis.</a:t>
+            </a:r>
+            <a:endParaRPr lang="en-US" sz="1400" dirty="0"/>
+          </a:p>
+        </p:txBody>
+      </p:sp>
+      <p:sp>
+        <p:nvSpPr>
+          <p:cNvPr id="5" name="Text 2"/>
           <p:cNvSpPr txBox="1"/>
           <p:nvPr/>
         </p:nvSpPr>
@@ -4993,7 +5649,7 @@
                 <a:ea typeface="Calibri" pitchFamily="34" charset="-122"/>
                 <a:cs typeface="Calibri" pitchFamily="34" charset="-120"/>
               </a:rPr>
-              <a:t>Indicadores Socioeconômicos · Unidade 1</a:t>
+              <a:t>Indicadores Socioeconômicos · Unidade 1 · Tópico 2 do sumário</a:t>
             </a:r>
             <a:endParaRPr lang="en-US" sz="950" dirty="0"/>
           </a:p>
@@ -5406,7 +6062,7 @@
                 <a:ea typeface="Calibri" pitchFamily="34" charset="-122"/>
                 <a:cs typeface="Calibri" pitchFamily="34" charset="-120"/>
               </a:rPr>
-              <a:t>Indicadores Socioeconômicos · Unidade 1</a:t>
+              <a:t>Indicadores Socioeconômicos · Unidade 1 · Tópico 2 do sumário</a:t>
             </a:r>
             <a:endParaRPr lang="en-US" sz="950" dirty="0"/>
           </a:p>
@@ -6018,7 +6674,7 @@
                           <a:ea typeface="Calibri" pitchFamily="34" charset="-122"/>
                           <a:cs typeface="Calibri" pitchFamily="34" charset="-120"/>
                         </a:rPr>
-                        <a:t>Analfabetismo: 900 analfabetos ÷ 9.000 pessoas de 15 anos ou mais</a:t>
+                        <a:t>Analfabetismo: 900 analfabetos ÷ 9.000 pessoas de 15 anos ou mais × 100</a:t>
                       </a:r>
                       <a:endParaRPr lang="en-US" sz="1300" dirty="0">
                         <a:latin typeface="Calibri" charset="0"/>
@@ -6498,7 +7154,7 @@
                           <a:ea typeface="Calibri" pitchFamily="34" charset="-122"/>
                           <a:cs typeface="Calibri" pitchFamily="34" charset="-120"/>
                         </a:rPr>
-                        <a:t>Base = 100</a:t>
+                        <a:t>Ano-base = 100</a:t>
                       </a:r>
                       <a:endParaRPr lang="en-US" sz="1300" dirty="0">
                         <a:latin typeface="Calibri" charset="0"/>
@@ -6636,7 +7292,7 @@
                 <a:ea typeface="Calibri" pitchFamily="34" charset="-122"/>
                 <a:cs typeface="Calibri" pitchFamily="34" charset="-120"/>
               </a:rPr>
-              <a:t>Indicadores Socioeconômicos · Unidade 1</a:t>
+              <a:t>Indicadores Socioeconômicos · Unidade 1 · Tópico 2 do sumário</a:t>
             </a:r>
             <a:endParaRPr lang="en-US" sz="950" dirty="0"/>
           </a:p>
@@ -7243,7 +7899,7 @@
                 <a:ea typeface="Calibri" pitchFamily="34" charset="-122"/>
                 <a:cs typeface="Calibri" pitchFamily="34" charset="-120"/>
               </a:rPr>
-              <a:t>Indicadores Socioeconômicos · Unidade 1</a:t>
+              <a:t>Indicadores Socioeconômicos · Unidade 1 · Tópico 2 do sumário</a:t>
             </a:r>
             <a:endParaRPr lang="en-US" sz="950" dirty="0"/>
           </a:p>
@@ -8242,7 +8898,7 @@
                 <a:ea typeface="Calibri" pitchFamily="34" charset="-122"/>
                 <a:cs typeface="Calibri" pitchFamily="34" charset="-120"/>
               </a:rPr>
-              <a:t>Indicadores Socioeconômicos · Unidade 1</a:t>
+              <a:t>Indicadores Socioeconômicos · Unidade 1 · Tópico 2 do sumário</a:t>
             </a:r>
             <a:endParaRPr lang="en-US" sz="950" dirty="0"/>
           </a:p>
@@ -8929,7 +9585,7 @@
                 <a:ea typeface="Calibri" pitchFamily="34" charset="-122"/>
                 <a:cs typeface="Calibri" pitchFamily="34" charset="-120"/>
               </a:rPr>
-              <a:t>Pesos e componentes são escolhas metodológicas.</a:t>
+              <a:t>Componentes e pesos são escolhas metodológicas (Guimarães e Jannuzzi, 2005).</a:t>
             </a:r>
             <a:endParaRPr lang="en-US" sz="1200" dirty="0"/>
           </a:p>
@@ -8971,7 +9627,7 @@
                 <a:ea typeface="Calibri" pitchFamily="34" charset="-122"/>
                 <a:cs typeface="Calibri" pitchFamily="34" charset="-120"/>
               </a:rPr>
-              <a:t>Indicadores Socioeconômicos · Unidade 1</a:t>
+              <a:t>Indicadores Socioeconômicos · Unidade 1 · Tópico 2 do sumário</a:t>
             </a:r>
             <a:endParaRPr lang="en-US" sz="950" dirty="0"/>
           </a:p>
@@ -9384,7 +10040,7 @@
                 <a:ea typeface="Calibri" pitchFamily="34" charset="-122"/>
                 <a:cs typeface="Calibri" pitchFamily="34" charset="-120"/>
               </a:rPr>
-              <a:t>Indicadores Socioeconômicos · Unidade 1</a:t>
+              <a:t>Indicadores Socioeconômicos · Unidade 1 · Tópico 2 do sumário</a:t>
             </a:r>
             <a:endParaRPr lang="en-US" sz="950" dirty="0"/>
           </a:p>
@@ -9797,7 +10453,7 @@
                 <a:ea typeface="Calibri" pitchFamily="34" charset="-122"/>
                 <a:cs typeface="Calibri" pitchFamily="34" charset="-120"/>
               </a:rPr>
-              <a:t>Indicadores Socioeconômicos · Unidade 1</a:t>
+              <a:t>Indicadores Socioeconômicos · Unidade 1 · Tópico 2 do sumário</a:t>
             </a:r>
             <a:endParaRPr lang="en-US" sz="950" dirty="0"/>
           </a:p>
@@ -11534,7 +12190,7 @@
                 <a:ea typeface="Calibri" pitchFamily="34" charset="-122"/>
                 <a:cs typeface="Calibri" pitchFamily="34" charset="-120"/>
               </a:rPr>
-              <a:t>Página de conteúdos: Unidades 1 e 2 · Fóruns de apresentação e temático 1</a:t>
+              <a:t>Página de conteúdos: tópicos 1 e 2 do sumário · Fóruns de apresentação e temático 1</a:t>
             </a:r>
             <a:endParaRPr lang="en-US" sz="1500" dirty="0"/>
           </a:p>
@@ -18180,7 +18836,7 @@
                 <a:ea typeface="Calibri" pitchFamily="34" charset="-122"/>
                 <a:cs typeface="Calibri" pitchFamily="34" charset="-120"/>
               </a:rPr>
-              <a:t>PARTE 1</a:t>
+              <a:t>PARTE 1 · TÓPICO 1 DO SUMÁRIO</a:t>
             </a:r>
             <a:endParaRPr lang="en-US" sz="1600" dirty="0"/>
           </a:p>
@@ -18273,6 +18929,557 @@
       <p:sp>
         <p:nvSpPr>
           <p:cNvPr id="5" name="Text 3"/>
+          <p:cNvSpPr txBox="1"/>
+          <p:nvPr/>
+        </p:nvSpPr>
+        <p:spPr>
+          <a:xfrm>
+            <a:off x="4206240" y="36576"/>
+            <a:ext cx="4800600" cy="219456"/>
+          </a:xfrm>
+          <a:prstGeom prst="rect">
+            <a:avLst/>
+          </a:prstGeom>
+          <a:noFill/>
+          <a:ln/>
+        </p:spPr>
+        <p:txBody>
+          <a:bodyPr wrap="square" lIns="0" tIns="0" rIns="0" bIns="0" rtlCol="0" anchor="ctr"/>
+          <a:lstStyle/>
+          <a:p>
+            <a:pPr algn="r" indent="0" marL="0">
+              <a:lnSpc>
+                <a:spcPct val="100000"/>
+              </a:lnSpc>
+              <a:buNone/>
+            </a:pPr>
+            <a:r>
+              <a:rPr lang="en-US" sz="950" dirty="0">
+                <a:solidFill>
+                  <a:srgbClr val="5B6770"/>
+                </a:solidFill>
+                <a:latin typeface="Calibri" pitchFamily="34" charset="0"/>
+                <a:ea typeface="Calibri" pitchFamily="34" charset="-122"/>
+                <a:cs typeface="Calibri" pitchFamily="34" charset="-120"/>
+              </a:rPr>
+              <a:t>Indicadores Socioeconômicos · Unidade 1 · Tópico 1 do sumário</a:t>
+            </a:r>
+            <a:endParaRPr lang="en-US" sz="950" dirty="0"/>
+          </a:p>
+        </p:txBody>
+      </p:sp>
+    </p:spTree>
+  </p:cSld>
+  <p:clrMapOvr>
+    <a:masterClrMapping/>
+  </p:clrMapOvr>
+</p:sld>
+</file>
+
+<file path=ppt/slides/slide30.xml><?xml version="1.0" encoding="utf-8"?>
+<p:sld xmlns:a="http://schemas.openxmlformats.org/drawingml/2006/main" xmlns:r="http://schemas.openxmlformats.org/officeDocument/2006/relationships" xmlns:p="http://schemas.openxmlformats.org/presentationml/2006/main">
+  <p:cSld name="Slide 30">
+    <p:bg>
+      <p:bgPr>
+        <a:blipFill dpi="0" rotWithShape="1">
+          <a:blip r:embed="rId1">
+            <a:lum/>
+          </a:blip>
+          <a:srcRect/>
+          <a:stretch>
+            <a:fillRect/>
+          </a:stretch>
+        </a:blipFill>
+        <a:effectLst/>
+      </p:bgPr>
+    </p:bg>
+    <p:spTree>
+      <p:nvGrpSpPr>
+        <p:cNvPr id="1" name=""/>
+        <p:cNvGrpSpPr/>
+        <p:nvPr/>
+      </p:nvGrpSpPr>
+      <p:grpSpPr>
+        <a:xfrm>
+          <a:off x="0" y="0"/>
+          <a:ext cx="0" cy="0"/>
+          <a:chOff x="0" y="0"/>
+          <a:chExt cx="0" cy="0"/>
+        </a:xfrm>
+      </p:grpSpPr>
+      <p:sp>
+        <p:nvSpPr>
+          <p:cNvPr id="2" name="Text 0"/>
+          <p:cNvSpPr txBox="1"/>
+          <p:nvPr/>
+        </p:nvSpPr>
+        <p:spPr>
+          <a:xfrm>
+            <a:off x="731520" y="256032"/>
+            <a:ext cx="7680960" cy="566928"/>
+          </a:xfrm>
+          <a:prstGeom prst="rect">
+            <a:avLst/>
+          </a:prstGeom>
+          <a:noFill/>
+          <a:ln/>
+        </p:spPr>
+        <p:txBody>
+          <a:bodyPr wrap="square" lIns="0" tIns="0" rIns="0" bIns="0" rtlCol="0" anchor="ctr"/>
+          <a:lstStyle/>
+          <a:p>
+            <a:pPr algn="ctr" indent="0" marL="0">
+              <a:lnSpc>
+                <a:spcPct val="100000"/>
+              </a:lnSpc>
+              <a:buNone/>
+            </a:pPr>
+            <a:r>
+              <a:rPr lang="en-US" sz="2800" b="1" dirty="0">
+                <a:solidFill>
+                  <a:srgbClr val="13294B"/>
+                </a:solidFill>
+                <a:latin typeface="Calibri" pitchFamily="34" charset="0"/>
+                <a:ea typeface="Calibri" pitchFamily="34" charset="-122"/>
+                <a:cs typeface="Calibri" pitchFamily="34" charset="-120"/>
+              </a:rPr>
+              <a:t>Resumo da Unidade 1</a:t>
+            </a:r>
+            <a:endParaRPr lang="en-US" sz="2800" dirty="0"/>
+          </a:p>
+        </p:txBody>
+      </p:sp>
+      <p:sp>
+        <p:nvSpPr>
+          <p:cNvPr id="3" name="Text 1"/>
+          <p:cNvSpPr txBox="1"/>
+          <p:nvPr/>
+        </p:nvSpPr>
+        <p:spPr>
+          <a:xfrm>
+            <a:off x="1005840" y="804672"/>
+            <a:ext cx="7132320" cy="329184"/>
+          </a:xfrm>
+          <a:prstGeom prst="rect">
+            <a:avLst/>
+          </a:prstGeom>
+          <a:noFill/>
+          <a:ln/>
+        </p:spPr>
+        <p:txBody>
+          <a:bodyPr wrap="square" lIns="0" tIns="0" rIns="0" bIns="0" rtlCol="0" anchor="ctr"/>
+          <a:lstStyle/>
+          <a:p>
+            <a:pPr algn="ctr" indent="0" marL="0">
+              <a:lnSpc>
+                <a:spcPct val="100000"/>
+              </a:lnSpc>
+              <a:buNone/>
+            </a:pPr>
+            <a:r>
+              <a:rPr lang="en-US" sz="1400" dirty="0">
+                <a:solidFill>
+                  <a:srgbClr val="5B6770"/>
+                </a:solidFill>
+                <a:latin typeface="Calibri" pitchFamily="34" charset="0"/>
+                <a:ea typeface="Calibri" pitchFamily="34" charset="-122"/>
+                <a:cs typeface="Calibri" pitchFamily="34" charset="-120"/>
+              </a:rPr>
+              <a:t>O que discutimos nesta unidade</a:t>
+            </a:r>
+            <a:endParaRPr lang="en-US" sz="1400" dirty="0"/>
+          </a:p>
+        </p:txBody>
+      </p:sp>
+      <p:sp>
+        <p:nvSpPr>
+          <p:cNvPr id="4" name="Text 2"/>
+          <p:cNvSpPr txBox="1"/>
+          <p:nvPr/>
+        </p:nvSpPr>
+        <p:spPr>
+          <a:xfrm>
+            <a:off x="685800" y="1170432"/>
+            <a:ext cx="3794760" cy="2743200"/>
+          </a:xfrm>
+          <a:prstGeom prst="roundRect">
+            <a:avLst>
+              <a:gd name="adj" fmla="val 2000"/>
+            </a:avLst>
+          </a:prstGeom>
+          <a:solidFill>
+            <a:srgbClr val="FFFFFF"/>
+          </a:solidFill>
+          <a:ln w="12700">
+            <a:solidFill>
+              <a:srgbClr val="DCD5C1"/>
+            </a:solidFill>
+          </a:ln>
+        </p:spPr>
+        <p:txBody>
+          <a:bodyPr wrap="square" lIns="114300" tIns="114300" rIns="114300" bIns="114300" rtlCol="0" anchor="t"/>
+          <a:lstStyle/>
+          <a:p>
+            <a:pPr algn="l" indent="0" marL="0">
+              <a:lnSpc>
+                <a:spcPct val="100000"/>
+              </a:lnSpc>
+              <a:spcAft>
+                <a:spcPts val="200"/>
+              </a:spcAft>
+              <a:buNone/>
+            </a:pPr>
+            <a:r>
+              <a:rPr lang="en-US" sz="1100" b="1" dirty="0">
+                <a:solidFill>
+                  <a:srgbClr val="2A8C85"/>
+                </a:solidFill>
+                <a:latin typeface="Calibri" pitchFamily="34" charset="0"/>
+                <a:ea typeface="Calibri" pitchFamily="34" charset="-122"/>
+                <a:cs typeface="Calibri" pitchFamily="34" charset="-120"/>
+              </a:rPr>
+              <a:t>PARTE 1 · TÓPICO 1</a:t>
+            </a:r>
+            <a:endParaRPr lang="en-US" sz="1100" dirty="0"/>
+          </a:p>
+          <a:p>
+            <a:pPr algn="l" indent="0" marL="0">
+              <a:lnSpc>
+                <a:spcPct val="100000"/>
+              </a:lnSpc>
+              <a:spcAft>
+                <a:spcPts val="400"/>
+              </a:spcAft>
+              <a:buNone/>
+            </a:pPr>
+            <a:r>
+              <a:rPr lang="en-US" sz="1450" b="1" dirty="0">
+                <a:solidFill>
+                  <a:srgbClr val="13294B"/>
+                </a:solidFill>
+                <a:latin typeface="Calibri" pitchFamily="34" charset="0"/>
+                <a:ea typeface="Calibri" pitchFamily="34" charset="-122"/>
+                <a:cs typeface="Calibri" pitchFamily="34" charset="-120"/>
+              </a:rPr>
+              <a:t>Uma breve caracterização histórica</a:t>
+            </a:r>
+            <a:endParaRPr lang="en-US" sz="1100" dirty="0"/>
+          </a:p>
+          <a:p>
+            <a:pPr algn="l" marL="177800" indent="-177800">
+              <a:lnSpc>
+                <a:spcPct val="100000"/>
+              </a:lnSpc>
+              <a:spcAft>
+                <a:spcPts val="300"/>
+              </a:spcAft>
+              <a:buSzPct val="100000"/>
+              <a:buChar char="•"/>
+            </a:pPr>
+            <a:r>
+              <a:rPr lang="en-US" sz="1200" dirty="0">
+                <a:solidFill>
+                  <a:srgbClr val="1F2A37"/>
+                </a:solidFill>
+                <a:latin typeface="Calibri" pitchFamily="34" charset="0"/>
+                <a:ea typeface="Calibri" pitchFamily="34" charset="-122"/>
+                <a:cs typeface="Calibri" pitchFamily="34" charset="-120"/>
+              </a:rPr>
+              <a:t>Indicadores servem para diagnosticar, planejar, monitorar, avaliar e para o controle social.</a:t>
+            </a:r>
+            <a:endParaRPr lang="en-US" sz="1100" dirty="0"/>
+          </a:p>
+          <a:p>
+            <a:pPr algn="l" marL="177800" indent="-177800">
+              <a:lnSpc>
+                <a:spcPct val="100000"/>
+              </a:lnSpc>
+              <a:spcAft>
+                <a:spcPts val="300"/>
+              </a:spcAft>
+              <a:buSzPct val="100000"/>
+              <a:buChar char="•"/>
+            </a:pPr>
+            <a:r>
+              <a:rPr lang="en-US" sz="1200" dirty="0">
+                <a:solidFill>
+                  <a:srgbClr val="1F2A37"/>
+                </a:solidFill>
+                <a:latin typeface="Calibri" pitchFamily="34" charset="0"/>
+                <a:ea typeface="Calibri" pitchFamily="34" charset="-122"/>
+                <a:cs typeface="Calibri" pitchFamily="34" charset="-120"/>
+              </a:rPr>
+              <a:t>Marcos: censos (1872 no Brasil), IBGE (1936), contas nacionais, movimento dos indicadores sociais (anos 1960), IDH (1990) e ODS.</a:t>
+            </a:r>
+            <a:endParaRPr lang="en-US" sz="1100" dirty="0"/>
+          </a:p>
+          <a:p>
+            <a:pPr algn="l" marL="177800" indent="-177800">
+              <a:lnSpc>
+                <a:spcPct val="100000"/>
+              </a:lnSpc>
+              <a:spcAft>
+                <a:spcPts val="300"/>
+              </a:spcAft>
+              <a:buSzPct val="100000"/>
+              <a:buChar char="•"/>
+            </a:pPr>
+            <a:r>
+              <a:rPr lang="en-US" sz="1200" dirty="0">
+                <a:solidFill>
+                  <a:srgbClr val="1F2A37"/>
+                </a:solidFill>
+                <a:latin typeface="Calibri" pitchFamily="34" charset="0"/>
+                <a:ea typeface="Calibri" pitchFamily="34" charset="-122"/>
+                <a:cs typeface="Calibri" pitchFamily="34" charset="-120"/>
+              </a:rPr>
+              <a:t>O PIB mede a produção, mas não a distribuição da renda nem o acesso a serviços.</a:t>
+            </a:r>
+            <a:endParaRPr lang="en-US" sz="1100" dirty="0"/>
+          </a:p>
+        </p:txBody>
+      </p:sp>
+      <p:sp>
+        <p:nvSpPr>
+          <p:cNvPr id="5" name="Text 3"/>
+          <p:cNvSpPr txBox="1"/>
+          <p:nvPr/>
+        </p:nvSpPr>
+        <p:spPr>
+          <a:xfrm>
+            <a:off x="4663440" y="1170432"/>
+            <a:ext cx="3794760" cy="2743200"/>
+          </a:xfrm>
+          <a:prstGeom prst="roundRect">
+            <a:avLst>
+              <a:gd name="adj" fmla="val 2000"/>
+            </a:avLst>
+          </a:prstGeom>
+          <a:solidFill>
+            <a:srgbClr val="E6F2F0"/>
+          </a:solidFill>
+          <a:ln/>
+        </p:spPr>
+        <p:txBody>
+          <a:bodyPr wrap="square" lIns="114300" tIns="114300" rIns="114300" bIns="114300" rtlCol="0" anchor="t"/>
+          <a:lstStyle/>
+          <a:p>
+            <a:pPr algn="l" indent="0" marL="0">
+              <a:lnSpc>
+                <a:spcPct val="100000"/>
+              </a:lnSpc>
+              <a:spcAft>
+                <a:spcPts val="200"/>
+              </a:spcAft>
+              <a:buNone/>
+            </a:pPr>
+            <a:r>
+              <a:rPr lang="en-US" sz="1100" b="1" dirty="0">
+                <a:solidFill>
+                  <a:srgbClr val="2A8C85"/>
+                </a:solidFill>
+                <a:latin typeface="Calibri" pitchFamily="34" charset="0"/>
+                <a:ea typeface="Calibri" pitchFamily="34" charset="-122"/>
+                <a:cs typeface="Calibri" pitchFamily="34" charset="-120"/>
+              </a:rPr>
+              <a:t>PARTE 2 · TÓPICO 2</a:t>
+            </a:r>
+            <a:endParaRPr lang="en-US" sz="1100" dirty="0"/>
+          </a:p>
+          <a:p>
+            <a:pPr algn="l" indent="0" marL="0">
+              <a:lnSpc>
+                <a:spcPct val="100000"/>
+              </a:lnSpc>
+              <a:spcAft>
+                <a:spcPts val="400"/>
+              </a:spcAft>
+              <a:buNone/>
+            </a:pPr>
+            <a:r>
+              <a:rPr lang="en-US" sz="1450" b="1" dirty="0">
+                <a:solidFill>
+                  <a:srgbClr val="13294B"/>
+                </a:solidFill>
+                <a:latin typeface="Calibri" pitchFamily="34" charset="0"/>
+                <a:ea typeface="Calibri" pitchFamily="34" charset="-122"/>
+                <a:cs typeface="Calibri" pitchFamily="34" charset="-120"/>
+              </a:rPr>
+              <a:t>Indicadores sociais: do conceito às medidas</a:t>
+            </a:r>
+            <a:endParaRPr lang="en-US" sz="1100" dirty="0"/>
+          </a:p>
+          <a:p>
+            <a:pPr algn="l" marL="177800" indent="-177800">
+              <a:lnSpc>
+                <a:spcPct val="100000"/>
+              </a:lnSpc>
+              <a:spcAft>
+                <a:spcPts val="300"/>
+              </a:spcAft>
+              <a:buSzPct val="100000"/>
+              <a:buChar char="•"/>
+            </a:pPr>
+            <a:r>
+              <a:rPr lang="en-US" sz="1200" dirty="0">
+                <a:solidFill>
+                  <a:srgbClr val="1F2A37"/>
+                </a:solidFill>
+                <a:latin typeface="Calibri" pitchFamily="34" charset="0"/>
+                <a:ea typeface="Calibri" pitchFamily="34" charset="-122"/>
+                <a:cs typeface="Calibri" pitchFamily="34" charset="-120"/>
+              </a:rPr>
+              <a:t>Indicador: medida com significado social que operacionaliza um conceito abstrato (Jannuzzi).</a:t>
+            </a:r>
+            <a:endParaRPr lang="en-US" sz="1100" dirty="0"/>
+          </a:p>
+          <a:p>
+            <a:pPr algn="l" marL="177800" indent="-177800">
+              <a:lnSpc>
+                <a:spcPct val="100000"/>
+              </a:lnSpc>
+              <a:spcAft>
+                <a:spcPts val="300"/>
+              </a:spcAft>
+              <a:buSzPct val="100000"/>
+              <a:buChar char="•"/>
+            </a:pPr>
+            <a:r>
+              <a:rPr lang="en-US" sz="1200" dirty="0">
+                <a:solidFill>
+                  <a:srgbClr val="1F2A37"/>
+                </a:solidFill>
+                <a:latin typeface="Calibri" pitchFamily="34" charset="0"/>
+                <a:ea typeface="Calibri" pitchFamily="34" charset="-122"/>
+                <a:cs typeface="Calibri" pitchFamily="34" charset="-120"/>
+              </a:rPr>
+              <a:t>Do conceito ao indicador: dimensões, dados e medida.</a:t>
+            </a:r>
+            <a:endParaRPr lang="en-US" sz="1100" dirty="0"/>
+          </a:p>
+          <a:p>
+            <a:pPr algn="l" marL="177800" indent="-177800">
+              <a:lnSpc>
+                <a:spcPct val="100000"/>
+              </a:lnSpc>
+              <a:spcAft>
+                <a:spcPts val="300"/>
+              </a:spcAft>
+              <a:buSzPct val="100000"/>
+              <a:buChar char="•"/>
+            </a:pPr>
+            <a:r>
+              <a:rPr lang="en-US" sz="1200" dirty="0">
+                <a:solidFill>
+                  <a:srgbClr val="1F2A37"/>
+                </a:solidFill>
+                <a:latin typeface="Calibri" pitchFamily="34" charset="0"/>
+                <a:ea typeface="Calibri" pitchFamily="34" charset="-122"/>
+                <a:cs typeface="Calibri" pitchFamily="34" charset="-120"/>
+              </a:rPr>
+              <a:t>Dado bruto, indicador e índice; taxas, proporções, razões e números-índice.</a:t>
+            </a:r>
+            <a:endParaRPr lang="en-US" sz="1100" dirty="0"/>
+          </a:p>
+          <a:p>
+            <a:pPr algn="l" marL="177800" indent="-177800">
+              <a:lnSpc>
+                <a:spcPct val="100000"/>
+              </a:lnSpc>
+              <a:spcAft>
+                <a:spcPts val="300"/>
+              </a:spcAft>
+              <a:buSzPct val="100000"/>
+              <a:buChar char="•"/>
+            </a:pPr>
+            <a:r>
+              <a:rPr lang="en-US" sz="1200" dirty="0">
+                <a:solidFill>
+                  <a:srgbClr val="1F2A37"/>
+                </a:solidFill>
+                <a:latin typeface="Calibri" pitchFamily="34" charset="0"/>
+                <a:ea typeface="Calibri" pitchFamily="34" charset="-122"/>
+                <a:cs typeface="Calibri" pitchFamily="34" charset="-120"/>
+              </a:rPr>
+              <a:t>Propriedades: relevância, validade, confiabilidade, sensibilidade, especificidade, desagregabilidade.</a:t>
+            </a:r>
+            <a:endParaRPr lang="en-US" sz="1100" dirty="0"/>
+          </a:p>
+          <a:p>
+            <a:pPr algn="l" marL="177800" indent="-177800">
+              <a:lnSpc>
+                <a:spcPct val="100000"/>
+              </a:lnSpc>
+              <a:spcAft>
+                <a:spcPts val="300"/>
+              </a:spcAft>
+              <a:buSzPct val="100000"/>
+              <a:buChar char="•"/>
+            </a:pPr>
+            <a:r>
+              <a:rPr lang="en-US" sz="1200" dirty="0">
+                <a:solidFill>
+                  <a:srgbClr val="1F2A37"/>
+                </a:solidFill>
+                <a:latin typeface="Calibri" pitchFamily="34" charset="0"/>
+                <a:ea typeface="Calibri" pitchFamily="34" charset="-122"/>
+                <a:cs typeface="Calibri" pitchFamily="34" charset="-120"/>
+              </a:rPr>
+              <a:t>Classificações e índices sintéticos (IDH, IDHM) com seus limites.</a:t>
+            </a:r>
+            <a:endParaRPr lang="en-US" sz="1100" dirty="0"/>
+          </a:p>
+        </p:txBody>
+      </p:sp>
+      <p:sp>
+        <p:nvSpPr>
+          <p:cNvPr id="6" name="Text 4"/>
+          <p:cNvSpPr txBox="1"/>
+          <p:nvPr/>
+        </p:nvSpPr>
+        <p:spPr>
+          <a:xfrm>
+            <a:off x="685800" y="3995928"/>
+            <a:ext cx="7772400" cy="484632"/>
+          </a:xfrm>
+          <a:prstGeom prst="roundRect">
+            <a:avLst>
+              <a:gd name="adj" fmla="val 15094"/>
+            </a:avLst>
+          </a:prstGeom>
+          <a:solidFill>
+            <a:srgbClr val="E6F2F0"/>
+          </a:solidFill>
+          <a:ln/>
+        </p:spPr>
+        <p:txBody>
+          <a:bodyPr wrap="square" lIns="127000" tIns="127000" rIns="127000" bIns="127000" rtlCol="0" anchor="ctr"/>
+          <a:lstStyle/>
+          <a:p>
+            <a:pPr algn="ctr" indent="0" marL="0">
+              <a:lnSpc>
+                <a:spcPct val="100000"/>
+              </a:lnSpc>
+              <a:buNone/>
+            </a:pPr>
+            <a:r>
+              <a:rPr lang="en-US" sz="1300" b="1" dirty="0">
+                <a:solidFill>
+                  <a:srgbClr val="13294B"/>
+                </a:solidFill>
+                <a:latin typeface="Calibri" pitchFamily="34" charset="0"/>
+                <a:ea typeface="Calibri" pitchFamily="34" charset="-122"/>
+                <a:cs typeface="Calibri" pitchFamily="34" charset="-120"/>
+              </a:rPr>
+              <a:t>Próxima unidade: indicadores no ciclo das políticas públicas e o diagnóstico socioeconômico.</a:t>
+            </a:r>
+            <a:endParaRPr lang="en-US" sz="1300" dirty="0"/>
+          </a:p>
+        </p:txBody>
+      </p:sp>
+      <p:sp>
+        <p:nvSpPr>
+          <p:cNvPr id="7" name="Text 5"/>
           <p:cNvSpPr txBox="1"/>
           <p:nvPr/>
         </p:nvSpPr>
@@ -19090,7 +20297,7 @@
                 <a:ea typeface="Calibri" pitchFamily="34" charset="-122"/>
                 <a:cs typeface="Calibri" pitchFamily="34" charset="-120"/>
               </a:rPr>
-              <a:t>Indicadores Socioeconômicos · Unidade 1</a:t>
+              <a:t>Indicadores Socioeconômicos · Unidade 1 · Tópico 1 do sumário</a:t>
             </a:r>
             <a:endParaRPr lang="en-US" sz="950" dirty="0"/>
           </a:p>
@@ -19459,7 +20666,7 @@
                 <a:ea typeface="Calibri" pitchFamily="34" charset="-122"/>
                 <a:cs typeface="Calibri" pitchFamily="34" charset="-120"/>
               </a:rPr>
-              <a:t>Crescer não bastava: era preciso medir saúde, educação e condições de vida.</a:t>
+              <a:t>Nos EUA: crescer não bastava; era preciso medir saúde, educação, moradia e condições de vida.</a:t>
             </a:r>
             <a:endParaRPr lang="en-US" sz="1100" dirty="0"/>
           </a:p>
@@ -19789,7 +20996,7 @@
                 <a:ea typeface="Calibri" pitchFamily="34" charset="-122"/>
                 <a:cs typeface="Calibri" pitchFamily="34" charset="-120"/>
               </a:rPr>
-              <a:t>Indicadores Socioeconômicos · Unidade 1</a:t>
+              <a:t>Indicadores Socioeconômicos · Unidade 1 · Tópico 1 do sumário</a:t>
             </a:r>
             <a:endParaRPr lang="en-US" sz="950" dirty="0"/>
           </a:p>
@@ -20308,7 +21515,7 @@
                 <a:ea typeface="Calibri" pitchFamily="34" charset="-122"/>
                 <a:cs typeface="Calibri" pitchFamily="34" charset="-120"/>
               </a:rPr>
-              <a:t>Indicadores Socioeconômicos · Unidade 1</a:t>
+              <a:t>Indicadores Socioeconômicos · Unidade 1 · Tópico 1 do sumário</a:t>
             </a:r>
             <a:endParaRPr lang="en-US" sz="950" dirty="0"/>
           </a:p>
@@ -20389,7 +21596,7 @@
                 <a:ea typeface="Calibri" pitchFamily="34" charset="-122"/>
                 <a:cs typeface="Calibri" pitchFamily="34" charset="-120"/>
               </a:rPr>
-              <a:t>PARTE 2</a:t>
+              <a:t>PARTE 2 · TÓPICO 2 DO SUMÁRIO</a:t>
             </a:r>
             <a:endParaRPr lang="en-US" sz="1600" dirty="0"/>
           </a:p>
@@ -20473,7 +21680,7 @@
                 <a:ea typeface="Calibri" pitchFamily="34" charset="-122"/>
                 <a:cs typeface="Calibri" pitchFamily="34" charset="-120"/>
               </a:rPr>
-              <a:t>Conceito, cálculo, propriedades e classificações</a:t>
+              <a:t>Conceito, cálculo, propriedades, classificações e índices sintéticos</a:t>
             </a:r>
             <a:endParaRPr lang="en-US" sz="1600" dirty="0"/>
           </a:p>
@@ -20515,7 +21722,7 @@
                 <a:ea typeface="Calibri" pitchFamily="34" charset="-122"/>
                 <a:cs typeface="Calibri" pitchFamily="34" charset="-120"/>
               </a:rPr>
-              <a:t>Indicadores Socioeconômicos · Unidade 1</a:t>
+              <a:t>Indicadores Socioeconômicos · Unidade 1 · Tópico 2 do sumário</a:t>
             </a:r>
             <a:endParaRPr lang="en-US" sz="950" dirty="0"/>
           </a:p>
@@ -20872,7 +22079,7 @@
                 <a:ea typeface="Calibri" pitchFamily="34" charset="-122"/>
                 <a:cs typeface="Calibri" pitchFamily="34" charset="-120"/>
               </a:rPr>
-              <a:t>Indicadores Socioeconômicos · Unidade 1</a:t>
+              <a:t>Indicadores Socioeconômicos · Unidade 1 · Tópico 2 do sumário</a:t>
             </a:r>
             <a:endParaRPr lang="en-US" sz="950" dirty="0"/>
           </a:p>
@@ -21459,7 +22666,7 @@
                 <a:ea typeface="Calibri" pitchFamily="34" charset="-122"/>
                 <a:cs typeface="Calibri" pitchFamily="34" charset="-120"/>
               </a:rPr>
-              <a:t>Indicadores Socioeconômicos · Unidade 1</a:t>
+              <a:t>Indicadores Socioeconômicos · Unidade 1 · Tópico 2 do sumário</a:t>
             </a:r>
             <a:endParaRPr lang="en-US" sz="950" dirty="0"/>
           </a:p>

</xml_diff>